<commit_message>
Project slide: frame it around the pains of hot desking
Rework docs/Hot-Desk-Monitor.pptx into pain -> fix rows: hunting for a
free desk -> live floor plan; ghost desks -> automatic release (20 min
after people leave, no-shows after 30); teams scattered -> team seating;
guesswork on space -> usage insights. Dashboard screenshot and key
figures move to the right; speaker notes walk through each pain.

Co-Authored-By: Claude Opus 5.5 <noreply@anthropic.com>
Claude-Session: https://claude.ai/code/session_01R5PsyFbuq2Dda7FuaF5nhy
</commit_message>
<xml_diff>
--- a/docs/Hot-Desk-Monitor.pptx
+++ b/docs/Hot-Desk-Monitor.pptx
@@ -107,7 +107,7 @@
   <p:extLst>
     <p:ext uri="{521415D9-36F7-43E2-AB2F-B90AF26B5E84}">
       <p14:sectionLst xmlns:p14="http://schemas.microsoft.com/office/powerpoint/2010/main">
-        <p14:section name="Overview" id="{4f65431f-c8b2-76d4-a3bf-239a3a1e76f7}">
+        <p14:section name="Overview" id="{cc1d1ca6-3d57-cb3e-40e3-e8c82a031ea6}">
           <p14:sldIdLst>
             <p14:sldId id="256"/>
           </p14:sldIdLst>
@@ -516,11 +516,12 @@
           <a:p>
             <a:r>
               <a:rPr lang="en-US" dirty="0"/>
-              <a:t>Hot Desk Monitor shows, live, which of the 125 hot desks at DIC Annex are free, and frees desks up automatically.
-Detection: under-desk presence sensors report through TTN or ChirpStack; every desk also has a QR label for check-in, so desks without sensors still work.
-Auto-release: a desk is held for 20 minutes after the person leaves, then becomes available. Check-ins last 3 hours by default and can be renewed by scanning again.
-Employees can reserve a slot ahead, team leads can book several seats, and the floor display helps people find colleagues.
-Admins get a live dashboard coloured by project team (8 teams), utilisation by zone and team, and capacity insights. It deploys to AWS from GitHub and can be demoed in GitHub Codespaces.</a:t>
+              <a:t>Hot desking only works if people can find a free desk quickly and desks are not blocked by people who are not using them. Hot Desk Monitor tackles four pains.
+1. Hunting for a free desk: instead of walking the floors, people see free desks on the live floor plan, on the office wall display, or on their phone.
+2. Ghost desks: desks held by a bag, or booked and never used. Under-desk sensors see when someone leaves; the desk frees itself 20 minutes later. Reservations nobody checks in to are released 30 minutes after the slot starts, and check-ins expire unless renewed.
+3. Teams scattered: occupied desks are coloured by project team, team leads can book several seats together, projects can have pre-allocated seats, and the colleague finder shows who is in and where.
+4. Guesswork on space: the dashboard shows utilisation by zone and project team, and the Insights page gives a capacity outlook (currently on simulated data until real sensor data builds up).
+Key figures: 125 desks on 2 floors at DIC Annex, 8 project teams, 20 minutes to free an empty desk, 3-hour default check-in. It deploys to AWS from GitHub and can be demoed in GitHub Codespaces.</a:t>
             </a:r>
             <a:endParaRPr lang="en-US" dirty="0"/>
           </a:p>
@@ -640,7 +641,7 @@
           <a:lstStyle>
             <a:lvl1pPr indent="0" marL="0">
               <a:buNone/>
-              <a:defRPr lang="en-US" sz="3200" b="1" dirty="0">
+              <a:defRPr lang="en-US" sz="3000" b="1" dirty="0">
                 <a:solidFill>
                   <a:schemeClr val="tx1"/>
                 </a:solidFill>
@@ -652,14 +653,14 @@
               <a:buNone/>
             </a:pPr>
             <a:r>
-              <a:rPr lang="en-US" sz="3200" b="1" dirty="0">
+              <a:rPr lang="en-US" sz="3000" b="1" dirty="0">
                 <a:solidFill>
                   <a:schemeClr val="tx1"/>
                 </a:solidFill>
               </a:rPr>
               <a:t>Title</a:t>
             </a:r>
-            <a:endParaRPr lang="en-US" sz="3200" dirty="0"/>
+            <a:endParaRPr lang="en-US" sz="3000" dirty="0"/>
           </a:p>
         </p:txBody>
       </p:sp>
@@ -1064,14 +1065,14 @@
               <a:buNone/>
             </a:pPr>
             <a:r>
-              <a:rPr lang="en-US" sz="3200" b="1" dirty="0">
+              <a:rPr lang="en-US" sz="3000" b="1" dirty="0">
                 <a:solidFill>
                   <a:schemeClr val="tx1"/>
                 </a:solidFill>
               </a:rPr>
-              <a:t>Hot Desk Monitor: live desk availability</a:t>
-            </a:r>
-            <a:endParaRPr lang="en-US" sz="3200" dirty="0"/>
+              <a:t>Hot Desk Monitor: taking the pain out of hot desking</a:t>
+            </a:r>
+            <a:endParaRPr lang="en-US" sz="3000" dirty="0"/>
           </a:p>
         </p:txBody>
       </p:sp>
@@ -1107,7 +1108,7 @@
                   <a:schemeClr val="tx2"/>
                 </a:solidFill>
               </a:rPr>
-              <a:t>Sensors and QR check-in show which of DIC Annex’s 125 hot desks are free, and free them up automatically when people leave.</a:t>
+              <a:t>Live sensor and check-in data for DIC Annex’s 125 hot desks, so people find a desk fast and desks never sit blocked.</a:t>
             </a:r>
             <a:endParaRPr lang="en-US" sz="1600" dirty="0"/>
           </a:p>
@@ -1115,32 +1116,135 @@
       </p:sp>
       <p:sp>
         <p:nvSpPr>
-          <p:cNvPr id="5" name="Icon circle 1"/>
+          <p:cNvPr id="5" name="Pain heading"/>
+          <p:cNvSpPr txBox="1"/>
+          <p:nvPr/>
+        </p:nvSpPr>
+        <p:spPr>
+          <a:xfrm>
+            <a:off x="621792" y="1755648"/>
+            <a:ext cx="2743200" cy="228600"/>
+          </a:xfrm>
+          <a:prstGeom prst="rect">
+            <a:avLst/>
+          </a:prstGeom>
+          <a:noFill/>
+          <a:ln/>
+        </p:spPr>
+        <p:txBody>
+          <a:bodyPr wrap="square" lIns="0" tIns="0" rIns="0" bIns="0" rtlCol="0" anchor="ctr"/>
+          <a:lstStyle/>
+          <a:p>
+            <a:pPr indent="0" marL="0">
+              <a:buNone/>
+            </a:pPr>
+            <a:r>
+              <a:rPr lang="en-US" sz="1100" b="1" spc="100" kern="0" dirty="0">
+                <a:solidFill>
+                  <a:schemeClr val="tx2"/>
+                </a:solidFill>
+              </a:rPr>
+              <a:t>THE PAIN</a:t>
+            </a:r>
+            <a:endParaRPr lang="en-US" sz="1100" dirty="0"/>
+          </a:p>
+        </p:txBody>
+      </p:sp>
+      <p:sp>
+        <p:nvSpPr>
+          <p:cNvPr id="6" name="Fix heading"/>
+          <p:cNvSpPr txBox="1"/>
+          <p:nvPr/>
+        </p:nvSpPr>
+        <p:spPr>
+          <a:xfrm>
+            <a:off x="4041648" y="1755648"/>
+            <a:ext cx="3108960" cy="228600"/>
+          </a:xfrm>
+          <a:prstGeom prst="rect">
+            <a:avLst/>
+          </a:prstGeom>
+          <a:noFill/>
+          <a:ln/>
+        </p:spPr>
+        <p:txBody>
+          <a:bodyPr wrap="square" lIns="0" tIns="0" rIns="0" bIns="0" rtlCol="0" anchor="ctr"/>
+          <a:lstStyle/>
+          <a:p>
+            <a:pPr indent="0" marL="0">
+              <a:buNone/>
+            </a:pPr>
+            <a:r>
+              <a:rPr lang="en-US" sz="1100" b="1" spc="100" kern="0" dirty="0">
+                <a:solidFill>
+                  <a:schemeClr val="tx2"/>
+                </a:solidFill>
+              </a:rPr>
+              <a:t>WHAT HOT DESK MONITOR DOES</a:t>
+            </a:r>
+            <a:endParaRPr lang="en-US" sz="1100" dirty="0"/>
+          </a:p>
+        </p:txBody>
+      </p:sp>
+      <p:sp>
+        <p:nvSpPr>
+          <p:cNvPr id="7" name="Row 1"/>
           <p:cNvSpPr/>
           <p:nvPr/>
         </p:nvSpPr>
         <p:spPr>
           <a:xfrm>
-            <a:off x="457200" y="1773936"/>
-            <a:ext cx="530352" cy="530352"/>
-          </a:xfrm>
-          <a:prstGeom prst="ellipse">
-            <a:avLst/>
-          </a:prstGeom>
-          <a:solidFill>
-            <a:schemeClr val="accent1"/>
+            <a:off x="457200" y="2057400"/>
+            <a:ext cx="6720840" cy="987552"/>
+          </a:xfrm>
+          <a:prstGeom prst="roundRect">
+            <a:avLst>
+              <a:gd name="adj" fmla="val 9259"/>
+            </a:avLst>
+          </a:prstGeom>
+          <a:solidFill>
+            <a:schemeClr val="bg2"/>
           </a:solidFill>
           <a:ln w="12700">
             <a:solidFill>
-              <a:schemeClr val="accent1"/>
+              <a:schemeClr val="bg2"/>
             </a:solidFill>
             <a:prstDash val="solid"/>
           </a:ln>
         </p:spPr>
       </p:sp>
+      <p:sp>
+        <p:nvSpPr>
+          <p:cNvPr id="8" name="Pain icon circle 1"/>
+          <p:cNvSpPr/>
+          <p:nvPr/>
+        </p:nvSpPr>
+        <p:spPr>
+          <a:xfrm>
+            <a:off x="621792" y="2313432"/>
+            <a:ext cx="475488" cy="475488"/>
+          </a:xfrm>
+          <a:prstGeom prst="ellipse">
+            <a:avLst/>
+          </a:prstGeom>
+          <a:solidFill>
+            <a:schemeClr val="accent6">
+              <a:alpha val="15000"/>
+            </a:schemeClr>
+          </a:solidFill>
+          <a:ln w="12700">
+            <a:solidFill>
+              <a:schemeClr val="accent6">
+                <a:alpha val="15000"/>
+              </a:schemeClr>
+            </a:solidFill>
+            <a:prstDash val="solid"/>
+          </a:ln>
+        </p:spPr>
+      </p:sp>
       <p:pic>
         <p:nvPicPr>
-          <p:cNvPr id="6" name="Icon 1" descr="Detect who is at each desk icon">    </p:cNvPr>
+          <p:cNvPr id="9" name="Pain icon 1" descr="Hunting for a free desk icon">    </p:cNvPr>
           <p:cNvPicPr>
             <a:picLocks noChangeAspect="1"/>
           </p:cNvPicPr>
@@ -1154,8 +1258,8 @@
         </p:blipFill>
         <p:spPr>
           <a:xfrm>
-            <a:off x="566928" y="1883664"/>
-            <a:ext cx="310896" cy="310896"/>
+            <a:off x="722376" y="2414016"/>
+            <a:ext cx="274320" cy="274320"/>
           </a:xfrm>
           <a:prstGeom prst="rect">
             <a:avLst/>
@@ -1164,14 +1268,14 @@
       </p:pic>
       <p:sp>
         <p:nvSpPr>
-          <p:cNvPr id="7" name="Capability 1"/>
+          <p:cNvPr id="10" name="Pain 1"/>
           <p:cNvSpPr txBox="1"/>
           <p:nvPr/>
         </p:nvSpPr>
         <p:spPr>
           <a:xfrm>
-            <a:off x="1188720" y="1737360"/>
-            <a:ext cx="4160520" cy="804672"/>
+            <a:off x="1243584" y="2148840"/>
+            <a:ext cx="2240280" cy="804672"/>
           </a:xfrm>
           <a:prstGeom prst="rect">
             <a:avLst/>
@@ -1180,7 +1284,7 @@
           <a:ln/>
         </p:spPr>
         <p:txBody>
-          <a:bodyPr wrap="square" lIns="0" tIns="0" rIns="0" bIns="0" rtlCol="0" anchor="t"/>
+          <a:bodyPr wrap="square" lIns="0" tIns="0" rIns="0" bIns="0" rtlCol="0" anchor="ctr"/>
           <a:lstStyle/>
           <a:p>
             <a:pPr indent="0" marL="0">
@@ -1190,14 +1294,14 @@
               <a:buNone/>
             </a:pPr>
             <a:r>
-              <a:rPr lang="en-US" sz="1600" b="1" dirty="0">
+              <a:rPr lang="en-US" sz="1500" b="1" dirty="0">
                 <a:solidFill>
                   <a:schemeClr val="tx1"/>
                 </a:solidFill>
               </a:rPr>
-              <a:t>Detect who is at each desk</a:t>
-            </a:r>
-            <a:endParaRPr lang="en-US" sz="1600" dirty="0"/>
+              <a:t>Hunting for a free desk</a:t>
+            </a:r>
+            <a:endParaRPr lang="en-US" sz="1500" dirty="0"/>
           </a:p>
           <a:p>
             <a:pPr indent="0" marL="0">
@@ -1212,24 +1316,24 @@
                   <a:schemeClr val="tx2"/>
                 </a:solidFill>
               </a:rPr>
-              <a:t>Under-desk sensors via TTN or ChirpStack, plus a QR code on every desk to check in</a:t>
-            </a:r>
-            <a:endParaRPr lang="en-US" sz="1600" dirty="0"/>
+              <a:t>Walking the floors to find a seat</a:t>
+            </a:r>
+            <a:endParaRPr lang="en-US" sz="1500" dirty="0"/>
           </a:p>
         </p:txBody>
       </p:sp>
       <p:sp>
         <p:nvSpPr>
-          <p:cNvPr id="8" name="Icon circle 2"/>
+          <p:cNvPr id="11" name="Arrow 1"/>
           <p:cNvSpPr/>
           <p:nvPr/>
         </p:nvSpPr>
         <p:spPr>
           <a:xfrm>
-            <a:off x="457200" y="2670048"/>
-            <a:ext cx="530352" cy="530352"/>
-          </a:xfrm>
-          <a:prstGeom prst="ellipse">
+            <a:off x="3593592" y="2441448"/>
+            <a:ext cx="292608" cy="219456"/>
+          </a:xfrm>
+          <a:prstGeom prst="rightArrow">
             <a:avLst/>
           </a:prstGeom>
           <a:solidFill>
@@ -1243,9 +1347,34 @@
           </a:ln>
         </p:spPr>
       </p:sp>
+      <p:sp>
+        <p:nvSpPr>
+          <p:cNvPr id="12" name="Fix icon circle 1"/>
+          <p:cNvSpPr/>
+          <p:nvPr/>
+        </p:nvSpPr>
+        <p:spPr>
+          <a:xfrm>
+            <a:off x="4041648" y="2313432"/>
+            <a:ext cx="475488" cy="475488"/>
+          </a:xfrm>
+          <a:prstGeom prst="ellipse">
+            <a:avLst/>
+          </a:prstGeom>
+          <a:solidFill>
+            <a:schemeClr val="accent1"/>
+          </a:solidFill>
+          <a:ln w="12700">
+            <a:solidFill>
+              <a:schemeClr val="accent1"/>
+            </a:solidFill>
+            <a:prstDash val="solid"/>
+          </a:ln>
+        </p:spPr>
+      </p:sp>
       <p:pic>
         <p:nvPicPr>
-          <p:cNvPr id="9" name="Icon 2" descr="Free desks automatically icon">    </p:cNvPr>
+          <p:cNvPr id="13" name="Fix icon 1" descr="Live floor plan icon">    </p:cNvPr>
           <p:cNvPicPr>
             <a:picLocks noChangeAspect="1"/>
           </p:cNvPicPr>
@@ -1259,8 +1388,8 @@
         </p:blipFill>
         <p:spPr>
           <a:xfrm>
-            <a:off x="566928" y="2779776"/>
-            <a:ext cx="310896" cy="310896"/>
+            <a:off x="4142232" y="2414016"/>
+            <a:ext cx="274320" cy="274320"/>
           </a:xfrm>
           <a:prstGeom prst="rect">
             <a:avLst/>
@@ -1269,14 +1398,14 @@
       </p:pic>
       <p:sp>
         <p:nvSpPr>
-          <p:cNvPr id="10" name="Capability 2"/>
+          <p:cNvPr id="14" name="Fix 1"/>
           <p:cNvSpPr txBox="1"/>
           <p:nvPr/>
         </p:nvSpPr>
         <p:spPr>
           <a:xfrm>
-            <a:off x="1188720" y="2633472"/>
-            <a:ext cx="4160520" cy="804672"/>
+            <a:off x="4663440" y="2148840"/>
+            <a:ext cx="2395728" cy="804672"/>
           </a:xfrm>
           <a:prstGeom prst="rect">
             <a:avLst/>
@@ -1285,7 +1414,7 @@
           <a:ln/>
         </p:spPr>
         <p:txBody>
-          <a:bodyPr wrap="square" lIns="0" tIns="0" rIns="0" bIns="0" rtlCol="0" anchor="t"/>
+          <a:bodyPr wrap="square" lIns="0" tIns="0" rIns="0" bIns="0" rtlCol="0" anchor="ctr"/>
           <a:lstStyle/>
           <a:p>
             <a:pPr indent="0" marL="0">
@@ -1295,14 +1424,14 @@
               <a:buNone/>
             </a:pPr>
             <a:r>
-              <a:rPr lang="en-US" sz="1600" b="1" dirty="0">
+              <a:rPr lang="en-US" sz="1500" b="1" dirty="0">
                 <a:solidFill>
                   <a:schemeClr val="tx1"/>
                 </a:solidFill>
               </a:rPr>
-              <a:t>Free desks automatically</a:t>
-            </a:r>
-            <a:endParaRPr lang="en-US" sz="1600" dirty="0"/>
+              <a:t>Live floor plan</a:t>
+            </a:r>
+            <a:endParaRPr lang="en-US" sz="1500" dirty="0"/>
           </a:p>
           <a:p>
             <a:pPr indent="0" marL="0">
@@ -1317,40 +1446,71 @@
                   <a:schemeClr val="tx2"/>
                 </a:solidFill>
               </a:rPr>
-              <a:t>Released 20 min after people leave; check-ins last 3 hours unless renewed</a:t>
-            </a:r>
-            <a:endParaRPr lang="en-US" sz="1600" dirty="0"/>
+              <a:t>Free desks on screen, wall display and phone</a:t>
+            </a:r>
+            <a:endParaRPr lang="en-US" sz="1500" dirty="0"/>
           </a:p>
         </p:txBody>
       </p:sp>
       <p:sp>
         <p:nvSpPr>
-          <p:cNvPr id="11" name="Icon circle 3"/>
+          <p:cNvPr id="15" name="Row 2"/>
           <p:cNvSpPr/>
           <p:nvPr/>
         </p:nvSpPr>
         <p:spPr>
           <a:xfrm>
-            <a:off x="457200" y="3566160"/>
-            <a:ext cx="530352" cy="530352"/>
-          </a:xfrm>
-          <a:prstGeom prst="ellipse">
-            <a:avLst/>
-          </a:prstGeom>
-          <a:solidFill>
-            <a:schemeClr val="accent1"/>
+            <a:off x="457200" y="3154680"/>
+            <a:ext cx="6720840" cy="987552"/>
+          </a:xfrm>
+          <a:prstGeom prst="roundRect">
+            <a:avLst>
+              <a:gd name="adj" fmla="val 9259"/>
+            </a:avLst>
+          </a:prstGeom>
+          <a:solidFill>
+            <a:schemeClr val="bg2"/>
           </a:solidFill>
           <a:ln w="12700">
             <a:solidFill>
-              <a:schemeClr val="accent1"/>
+              <a:schemeClr val="bg2"/>
             </a:solidFill>
             <a:prstDash val="solid"/>
           </a:ln>
         </p:spPr>
       </p:sp>
+      <p:sp>
+        <p:nvSpPr>
+          <p:cNvPr id="16" name="Pain icon circle 2"/>
+          <p:cNvSpPr/>
+          <p:nvPr/>
+        </p:nvSpPr>
+        <p:spPr>
+          <a:xfrm>
+            <a:off x="621792" y="3410712"/>
+            <a:ext cx="475488" cy="475488"/>
+          </a:xfrm>
+          <a:prstGeom prst="ellipse">
+            <a:avLst/>
+          </a:prstGeom>
+          <a:solidFill>
+            <a:schemeClr val="accent6">
+              <a:alpha val="15000"/>
+            </a:schemeClr>
+          </a:solidFill>
+          <a:ln w="12700">
+            <a:solidFill>
+              <a:schemeClr val="accent6">
+                <a:alpha val="15000"/>
+              </a:schemeClr>
+            </a:solidFill>
+            <a:prstDash val="solid"/>
+          </a:ln>
+        </p:spPr>
+      </p:sp>
       <p:pic>
         <p:nvPicPr>
-          <p:cNvPr id="12" name="Icon 3" descr="Book and find icon">    </p:cNvPr>
+          <p:cNvPr id="17" name="Pain icon 2" descr="Ghost desks icon">    </p:cNvPr>
           <p:cNvPicPr>
             <a:picLocks noChangeAspect="1"/>
           </p:cNvPicPr>
@@ -1364,8 +1524,8 @@
         </p:blipFill>
         <p:spPr>
           <a:xfrm>
-            <a:off x="566928" y="3675888"/>
-            <a:ext cx="310896" cy="310896"/>
+            <a:off x="722376" y="3511296"/>
+            <a:ext cx="274320" cy="274320"/>
           </a:xfrm>
           <a:prstGeom prst="rect">
             <a:avLst/>
@@ -1374,14 +1534,14 @@
       </p:pic>
       <p:sp>
         <p:nvSpPr>
-          <p:cNvPr id="13" name="Capability 3"/>
+          <p:cNvPr id="18" name="Pain 2"/>
           <p:cNvSpPr txBox="1"/>
           <p:nvPr/>
         </p:nvSpPr>
         <p:spPr>
           <a:xfrm>
-            <a:off x="1188720" y="3529584"/>
-            <a:ext cx="4160520" cy="804672"/>
+            <a:off x="1243584" y="3246120"/>
+            <a:ext cx="2240280" cy="804672"/>
           </a:xfrm>
           <a:prstGeom prst="rect">
             <a:avLst/>
@@ -1390,7 +1550,7 @@
           <a:ln/>
         </p:spPr>
         <p:txBody>
-          <a:bodyPr wrap="square" lIns="0" tIns="0" rIns="0" bIns="0" rtlCol="0" anchor="t"/>
+          <a:bodyPr wrap="square" lIns="0" tIns="0" rIns="0" bIns="0" rtlCol="0" anchor="ctr"/>
           <a:lstStyle/>
           <a:p>
             <a:pPr indent="0" marL="0">
@@ -1400,14 +1560,14 @@
               <a:buNone/>
             </a:pPr>
             <a:r>
-              <a:rPr lang="en-US" sz="1600" b="1" dirty="0">
+              <a:rPr lang="en-US" sz="1500" b="1" dirty="0">
                 <a:solidFill>
                   <a:schemeClr val="tx1"/>
                 </a:solidFill>
               </a:rPr>
-              <a:t>Book and find</a:t>
-            </a:r>
-            <a:endParaRPr lang="en-US" sz="1600" dirty="0"/>
+              <a:t>Ghost desks</a:t>
+            </a:r>
+            <a:endParaRPr lang="en-US" sz="1500" dirty="0"/>
           </a:p>
           <a:p>
             <a:pPr indent="0" marL="0">
@@ -1422,24 +1582,24 @@
                   <a:schemeClr val="tx2"/>
                 </a:solidFill>
               </a:rPr>
-              <a:t>Reserve a slot ahead, book seats for a team, find colleagues on the floor display</a:t>
-            </a:r>
-            <a:endParaRPr lang="en-US" sz="1600" dirty="0"/>
+              <a:t>Held by a bag, or booked and never used</a:t>
+            </a:r>
+            <a:endParaRPr lang="en-US" sz="1500" dirty="0"/>
           </a:p>
         </p:txBody>
       </p:sp>
       <p:sp>
         <p:nvSpPr>
-          <p:cNvPr id="14" name="Icon circle 4"/>
+          <p:cNvPr id="19" name="Arrow 2"/>
           <p:cNvSpPr/>
           <p:nvPr/>
         </p:nvSpPr>
         <p:spPr>
           <a:xfrm>
-            <a:off x="457200" y="4462272"/>
-            <a:ext cx="530352" cy="530352"/>
-          </a:xfrm>
-          <a:prstGeom prst="ellipse">
+            <a:off x="3593592" y="3538728"/>
+            <a:ext cx="292608" cy="219456"/>
+          </a:xfrm>
+          <a:prstGeom prst="rightArrow">
             <a:avLst/>
           </a:prstGeom>
           <a:solidFill>
@@ -1453,9 +1613,34 @@
           </a:ln>
         </p:spPr>
       </p:sp>
+      <p:sp>
+        <p:nvSpPr>
+          <p:cNvPr id="20" name="Fix icon circle 2"/>
+          <p:cNvSpPr/>
+          <p:nvPr/>
+        </p:nvSpPr>
+        <p:spPr>
+          <a:xfrm>
+            <a:off x="4041648" y="3410712"/>
+            <a:ext cx="475488" cy="475488"/>
+          </a:xfrm>
+          <a:prstGeom prst="ellipse">
+            <a:avLst/>
+          </a:prstGeom>
+          <a:solidFill>
+            <a:schemeClr val="accent1"/>
+          </a:solidFill>
+          <a:ln w="12700">
+            <a:solidFill>
+              <a:schemeClr val="accent1"/>
+            </a:solidFill>
+            <a:prstDash val="solid"/>
+          </a:ln>
+        </p:spPr>
+      </p:sp>
       <p:pic>
         <p:nvPicPr>
-          <p:cNvPr id="15" name="Icon 4" descr="Manage and plan icon">    </p:cNvPr>
+          <p:cNvPr id="21" name="Fix icon 2" descr="Automatic release icon">    </p:cNvPr>
           <p:cNvPicPr>
             <a:picLocks noChangeAspect="1"/>
           </p:cNvPicPr>
@@ -1469,8 +1654,8 @@
         </p:blipFill>
         <p:spPr>
           <a:xfrm>
-            <a:off x="566928" y="4572000"/>
-            <a:ext cx="310896" cy="310896"/>
+            <a:off x="4142232" y="3511296"/>
+            <a:ext cx="274320" cy="274320"/>
           </a:xfrm>
           <a:prstGeom prst="rect">
             <a:avLst/>
@@ -1479,14 +1664,14 @@
       </p:pic>
       <p:sp>
         <p:nvSpPr>
-          <p:cNvPr id="16" name="Capability 4"/>
+          <p:cNvPr id="22" name="Fix 2"/>
           <p:cNvSpPr txBox="1"/>
           <p:nvPr/>
         </p:nvSpPr>
         <p:spPr>
           <a:xfrm>
-            <a:off x="1188720" y="4425696"/>
-            <a:ext cx="4160520" cy="804672"/>
+            <a:off x="4663440" y="3246120"/>
+            <a:ext cx="2395728" cy="804672"/>
           </a:xfrm>
           <a:prstGeom prst="rect">
             <a:avLst/>
@@ -1495,7 +1680,7 @@
           <a:ln/>
         </p:spPr>
         <p:txBody>
-          <a:bodyPr wrap="square" lIns="0" tIns="0" rIns="0" bIns="0" rtlCol="0" anchor="t"/>
+          <a:bodyPr wrap="square" lIns="0" tIns="0" rIns="0" bIns="0" rtlCol="0" anchor="ctr"/>
           <a:lstStyle/>
           <a:p>
             <a:pPr indent="0" marL="0">
@@ -1505,14 +1690,14 @@
               <a:buNone/>
             </a:pPr>
             <a:r>
-              <a:rPr lang="en-US" sz="1600" b="1" dirty="0">
+              <a:rPr lang="en-US" sz="1500" b="1" dirty="0">
                 <a:solidFill>
                   <a:schemeClr val="tx1"/>
                 </a:solidFill>
               </a:rPr>
-              <a:t>Manage and plan</a:t>
-            </a:r>
-            <a:endParaRPr lang="en-US" sz="1600" dirty="0"/>
+              <a:t>Automatic release</a:t>
+            </a:r>
+            <a:endParaRPr lang="en-US" sz="1500" dirty="0"/>
           </a:p>
           <a:p>
             <a:pPr indent="0" marL="0">
@@ -1527,26 +1712,558 @@
                   <a:schemeClr val="tx2"/>
                 </a:solidFill>
               </a:rPr>
-              <a:t>Live dashboard by project team, utilisation and capacity insights; runs on AWS</a:t>
-            </a:r>
-            <a:endParaRPr lang="en-US" sz="1600" dirty="0"/>
+              <a:t>Freed 20 min after people leave; no-shows after 30</a:t>
+            </a:r>
+            <a:endParaRPr lang="en-US" sz="1500" dirty="0"/>
           </a:p>
         </p:txBody>
       </p:sp>
       <p:sp>
         <p:nvSpPr>
-          <p:cNvPr id="17" name="Screenshot frame"/>
+          <p:cNvPr id="23" name="Row 3"/>
           <p:cNvSpPr/>
           <p:nvPr/>
         </p:nvSpPr>
         <p:spPr>
           <a:xfrm>
-            <a:off x="5916168" y="1664208"/>
-            <a:ext cx="5870448" cy="3710178"/>
+            <a:off x="457200" y="4251960"/>
+            <a:ext cx="6720840" cy="987552"/>
           </a:xfrm>
           <a:prstGeom prst="roundRect">
             <a:avLst>
-              <a:gd name="adj" fmla="val 1972"/>
+              <a:gd name="adj" fmla="val 9259"/>
+            </a:avLst>
+          </a:prstGeom>
+          <a:solidFill>
+            <a:schemeClr val="bg2"/>
+          </a:solidFill>
+          <a:ln w="12700">
+            <a:solidFill>
+              <a:schemeClr val="bg2"/>
+            </a:solidFill>
+            <a:prstDash val="solid"/>
+          </a:ln>
+        </p:spPr>
+      </p:sp>
+      <p:sp>
+        <p:nvSpPr>
+          <p:cNvPr id="24" name="Pain icon circle 3"/>
+          <p:cNvSpPr/>
+          <p:nvPr/>
+        </p:nvSpPr>
+        <p:spPr>
+          <a:xfrm>
+            <a:off x="621792" y="4507992"/>
+            <a:ext cx="475488" cy="475488"/>
+          </a:xfrm>
+          <a:prstGeom prst="ellipse">
+            <a:avLst/>
+          </a:prstGeom>
+          <a:solidFill>
+            <a:schemeClr val="accent6">
+              <a:alpha val="15000"/>
+            </a:schemeClr>
+          </a:solidFill>
+          <a:ln w="12700">
+            <a:solidFill>
+              <a:schemeClr val="accent6">
+                <a:alpha val="15000"/>
+              </a:schemeClr>
+            </a:solidFill>
+            <a:prstDash val="solid"/>
+          </a:ln>
+        </p:spPr>
+      </p:sp>
+      <p:pic>
+        <p:nvPicPr>
+          <p:cNvPr id="25" name="Pain icon 3" descr="Teams scattered icon">    </p:cNvPr>
+          <p:cNvPicPr>
+            <a:picLocks noChangeAspect="1"/>
+          </p:cNvPicPr>
+          <p:nvPr/>
+        </p:nvPicPr>
+        <p:blipFill>
+          <a:blip r:embed="rId6"/>
+          <a:stretch>
+            <a:fillRect/>
+          </a:stretch>
+        </p:blipFill>
+        <p:spPr>
+          <a:xfrm>
+            <a:off x="722376" y="4608576"/>
+            <a:ext cx="274320" cy="274320"/>
+          </a:xfrm>
+          <a:prstGeom prst="rect">
+            <a:avLst/>
+          </a:prstGeom>
+        </p:spPr>
+      </p:pic>
+      <p:sp>
+        <p:nvSpPr>
+          <p:cNvPr id="26" name="Pain 3"/>
+          <p:cNvSpPr txBox="1"/>
+          <p:nvPr/>
+        </p:nvSpPr>
+        <p:spPr>
+          <a:xfrm>
+            <a:off x="1243584" y="4343400"/>
+            <a:ext cx="2240280" cy="804672"/>
+          </a:xfrm>
+          <a:prstGeom prst="rect">
+            <a:avLst/>
+          </a:prstGeom>
+          <a:noFill/>
+          <a:ln/>
+        </p:spPr>
+        <p:txBody>
+          <a:bodyPr wrap="square" lIns="0" tIns="0" rIns="0" bIns="0" rtlCol="0" anchor="ctr"/>
+          <a:lstStyle/>
+          <a:p>
+            <a:pPr indent="0" marL="0">
+              <a:spcAft>
+                <a:spcPts val="200"/>
+              </a:spcAft>
+              <a:buNone/>
+            </a:pPr>
+            <a:r>
+              <a:rPr lang="en-US" sz="1500" b="1" dirty="0">
+                <a:solidFill>
+                  <a:schemeClr val="tx1"/>
+                </a:solidFill>
+              </a:rPr>
+              <a:t>Teams scattered</a:t>
+            </a:r>
+            <a:endParaRPr lang="en-US" sz="1500" dirty="0"/>
+          </a:p>
+          <a:p>
+            <a:pPr indent="0" marL="0">
+              <a:spcAft>
+                <a:spcPts val="200"/>
+              </a:spcAft>
+              <a:buNone/>
+            </a:pPr>
+            <a:r>
+              <a:rPr lang="en-US" sz="1400" dirty="0">
+                <a:solidFill>
+                  <a:schemeClr val="tx2"/>
+                </a:solidFill>
+              </a:rPr>
+              <a:t>Hard to sit together or find colleagues</a:t>
+            </a:r>
+            <a:endParaRPr lang="en-US" sz="1500" dirty="0"/>
+          </a:p>
+        </p:txBody>
+      </p:sp>
+      <p:sp>
+        <p:nvSpPr>
+          <p:cNvPr id="27" name="Arrow 3"/>
+          <p:cNvSpPr/>
+          <p:nvPr/>
+        </p:nvSpPr>
+        <p:spPr>
+          <a:xfrm>
+            <a:off x="3593592" y="4636008"/>
+            <a:ext cx="292608" cy="219456"/>
+          </a:xfrm>
+          <a:prstGeom prst="rightArrow">
+            <a:avLst/>
+          </a:prstGeom>
+          <a:solidFill>
+            <a:schemeClr val="accent1"/>
+          </a:solidFill>
+          <a:ln w="12700">
+            <a:solidFill>
+              <a:schemeClr val="accent1"/>
+            </a:solidFill>
+            <a:prstDash val="solid"/>
+          </a:ln>
+        </p:spPr>
+      </p:sp>
+      <p:sp>
+        <p:nvSpPr>
+          <p:cNvPr id="28" name="Fix icon circle 3"/>
+          <p:cNvSpPr/>
+          <p:nvPr/>
+        </p:nvSpPr>
+        <p:spPr>
+          <a:xfrm>
+            <a:off x="4041648" y="4507992"/>
+            <a:ext cx="475488" cy="475488"/>
+          </a:xfrm>
+          <a:prstGeom prst="ellipse">
+            <a:avLst/>
+          </a:prstGeom>
+          <a:solidFill>
+            <a:schemeClr val="accent1"/>
+          </a:solidFill>
+          <a:ln w="12700">
+            <a:solidFill>
+              <a:schemeClr val="accent1"/>
+            </a:solidFill>
+            <a:prstDash val="solid"/>
+          </a:ln>
+        </p:spPr>
+      </p:sp>
+      <p:pic>
+        <p:nvPicPr>
+          <p:cNvPr id="29" name="Fix icon 3" descr="Team seating icon">    </p:cNvPr>
+          <p:cNvPicPr>
+            <a:picLocks noChangeAspect="1"/>
+          </p:cNvPicPr>
+          <p:nvPr/>
+        </p:nvPicPr>
+        <p:blipFill>
+          <a:blip r:embed="rId7"/>
+          <a:stretch>
+            <a:fillRect/>
+          </a:stretch>
+        </p:blipFill>
+        <p:spPr>
+          <a:xfrm>
+            <a:off x="4142232" y="4608576"/>
+            <a:ext cx="274320" cy="274320"/>
+          </a:xfrm>
+          <a:prstGeom prst="rect">
+            <a:avLst/>
+          </a:prstGeom>
+        </p:spPr>
+      </p:pic>
+      <p:sp>
+        <p:nvSpPr>
+          <p:cNvPr id="30" name="Fix 3"/>
+          <p:cNvSpPr txBox="1"/>
+          <p:nvPr/>
+        </p:nvSpPr>
+        <p:spPr>
+          <a:xfrm>
+            <a:off x="4663440" y="4343400"/>
+            <a:ext cx="2395728" cy="804672"/>
+          </a:xfrm>
+          <a:prstGeom prst="rect">
+            <a:avLst/>
+          </a:prstGeom>
+          <a:noFill/>
+          <a:ln/>
+        </p:spPr>
+        <p:txBody>
+          <a:bodyPr wrap="square" lIns="0" tIns="0" rIns="0" bIns="0" rtlCol="0" anchor="ctr"/>
+          <a:lstStyle/>
+          <a:p>
+            <a:pPr indent="0" marL="0">
+              <a:spcAft>
+                <a:spcPts val="200"/>
+              </a:spcAft>
+              <a:buNone/>
+            </a:pPr>
+            <a:r>
+              <a:rPr lang="en-US" sz="1500" b="1" dirty="0">
+                <a:solidFill>
+                  <a:schemeClr val="tx1"/>
+                </a:solidFill>
+              </a:rPr>
+              <a:t>Team seating</a:t>
+            </a:r>
+            <a:endParaRPr lang="en-US" sz="1500" dirty="0"/>
+          </a:p>
+          <a:p>
+            <a:pPr indent="0" marL="0">
+              <a:spcAft>
+                <a:spcPts val="200"/>
+              </a:spcAft>
+              <a:buNone/>
+            </a:pPr>
+            <a:r>
+              <a:rPr lang="en-US" sz="1400" dirty="0">
+                <a:solidFill>
+                  <a:schemeClr val="tx2"/>
+                </a:solidFill>
+              </a:rPr>
+              <a:t>Team colours, team bookings, colleague finder</a:t>
+            </a:r>
+            <a:endParaRPr lang="en-US" sz="1500" dirty="0"/>
+          </a:p>
+        </p:txBody>
+      </p:sp>
+      <p:sp>
+        <p:nvSpPr>
+          <p:cNvPr id="31" name="Row 4"/>
+          <p:cNvSpPr/>
+          <p:nvPr/>
+        </p:nvSpPr>
+        <p:spPr>
+          <a:xfrm>
+            <a:off x="457200" y="5349240"/>
+            <a:ext cx="6720840" cy="987552"/>
+          </a:xfrm>
+          <a:prstGeom prst="roundRect">
+            <a:avLst>
+              <a:gd name="adj" fmla="val 9259"/>
+            </a:avLst>
+          </a:prstGeom>
+          <a:solidFill>
+            <a:schemeClr val="bg2"/>
+          </a:solidFill>
+          <a:ln w="12700">
+            <a:solidFill>
+              <a:schemeClr val="bg2"/>
+            </a:solidFill>
+            <a:prstDash val="solid"/>
+          </a:ln>
+        </p:spPr>
+      </p:sp>
+      <p:sp>
+        <p:nvSpPr>
+          <p:cNvPr id="32" name="Pain icon circle 4"/>
+          <p:cNvSpPr/>
+          <p:nvPr/>
+        </p:nvSpPr>
+        <p:spPr>
+          <a:xfrm>
+            <a:off x="621792" y="5605272"/>
+            <a:ext cx="475488" cy="475488"/>
+          </a:xfrm>
+          <a:prstGeom prst="ellipse">
+            <a:avLst/>
+          </a:prstGeom>
+          <a:solidFill>
+            <a:schemeClr val="accent6">
+              <a:alpha val="15000"/>
+            </a:schemeClr>
+          </a:solidFill>
+          <a:ln w="12700">
+            <a:solidFill>
+              <a:schemeClr val="accent6">
+                <a:alpha val="15000"/>
+              </a:schemeClr>
+            </a:solidFill>
+            <a:prstDash val="solid"/>
+          </a:ln>
+        </p:spPr>
+      </p:sp>
+      <p:pic>
+        <p:nvPicPr>
+          <p:cNvPr id="33" name="Pain icon 4" descr="Guesswork on space icon">    </p:cNvPr>
+          <p:cNvPicPr>
+            <a:picLocks noChangeAspect="1"/>
+          </p:cNvPicPr>
+          <p:nvPr/>
+        </p:nvPicPr>
+        <p:blipFill>
+          <a:blip r:embed="rId8"/>
+          <a:stretch>
+            <a:fillRect/>
+          </a:stretch>
+        </p:blipFill>
+        <p:spPr>
+          <a:xfrm>
+            <a:off x="722376" y="5705856"/>
+            <a:ext cx="274320" cy="274320"/>
+          </a:xfrm>
+          <a:prstGeom prst="rect">
+            <a:avLst/>
+          </a:prstGeom>
+        </p:spPr>
+      </p:pic>
+      <p:sp>
+        <p:nvSpPr>
+          <p:cNvPr id="34" name="Pain 4"/>
+          <p:cNvSpPr txBox="1"/>
+          <p:nvPr/>
+        </p:nvSpPr>
+        <p:spPr>
+          <a:xfrm>
+            <a:off x="1243584" y="5440680"/>
+            <a:ext cx="2240280" cy="804672"/>
+          </a:xfrm>
+          <a:prstGeom prst="rect">
+            <a:avLst/>
+          </a:prstGeom>
+          <a:noFill/>
+          <a:ln/>
+        </p:spPr>
+        <p:txBody>
+          <a:bodyPr wrap="square" lIns="0" tIns="0" rIns="0" bIns="0" rtlCol="0" anchor="ctr"/>
+          <a:lstStyle/>
+          <a:p>
+            <a:pPr indent="0" marL="0">
+              <a:spcAft>
+                <a:spcPts val="200"/>
+              </a:spcAft>
+              <a:buNone/>
+            </a:pPr>
+            <a:r>
+              <a:rPr lang="en-US" sz="1500" b="1" dirty="0">
+                <a:solidFill>
+                  <a:schemeClr val="tx1"/>
+                </a:solidFill>
+              </a:rPr>
+              <a:t>Guesswork on space</a:t>
+            </a:r>
+            <a:endParaRPr lang="en-US" sz="1500" dirty="0"/>
+          </a:p>
+          <a:p>
+            <a:pPr indent="0" marL="0">
+              <a:spcAft>
+                <a:spcPts val="200"/>
+              </a:spcAft>
+              <a:buNone/>
+            </a:pPr>
+            <a:r>
+              <a:rPr lang="en-US" sz="1400" dirty="0">
+                <a:solidFill>
+                  <a:schemeClr val="tx2"/>
+                </a:solidFill>
+              </a:rPr>
+              <a:t>No data on how desks are really used</a:t>
+            </a:r>
+            <a:endParaRPr lang="en-US" sz="1500" dirty="0"/>
+          </a:p>
+        </p:txBody>
+      </p:sp>
+      <p:sp>
+        <p:nvSpPr>
+          <p:cNvPr id="35" name="Arrow 4"/>
+          <p:cNvSpPr/>
+          <p:nvPr/>
+        </p:nvSpPr>
+        <p:spPr>
+          <a:xfrm>
+            <a:off x="3593592" y="5733288"/>
+            <a:ext cx="292608" cy="219456"/>
+          </a:xfrm>
+          <a:prstGeom prst="rightArrow">
+            <a:avLst/>
+          </a:prstGeom>
+          <a:solidFill>
+            <a:schemeClr val="accent1"/>
+          </a:solidFill>
+          <a:ln w="12700">
+            <a:solidFill>
+              <a:schemeClr val="accent1"/>
+            </a:solidFill>
+            <a:prstDash val="solid"/>
+          </a:ln>
+        </p:spPr>
+      </p:sp>
+      <p:sp>
+        <p:nvSpPr>
+          <p:cNvPr id="36" name="Fix icon circle 4"/>
+          <p:cNvSpPr/>
+          <p:nvPr/>
+        </p:nvSpPr>
+        <p:spPr>
+          <a:xfrm>
+            <a:off x="4041648" y="5605272"/>
+            <a:ext cx="475488" cy="475488"/>
+          </a:xfrm>
+          <a:prstGeom prst="ellipse">
+            <a:avLst/>
+          </a:prstGeom>
+          <a:solidFill>
+            <a:schemeClr val="accent1"/>
+          </a:solidFill>
+          <a:ln w="12700">
+            <a:solidFill>
+              <a:schemeClr val="accent1"/>
+            </a:solidFill>
+            <a:prstDash val="solid"/>
+          </a:ln>
+        </p:spPr>
+      </p:sp>
+      <p:pic>
+        <p:nvPicPr>
+          <p:cNvPr id="37" name="Fix icon 4" descr="Usage insights icon">    </p:cNvPr>
+          <p:cNvPicPr>
+            <a:picLocks noChangeAspect="1"/>
+          </p:cNvPicPr>
+          <p:nvPr/>
+        </p:nvPicPr>
+        <p:blipFill>
+          <a:blip r:embed="rId9"/>
+          <a:stretch>
+            <a:fillRect/>
+          </a:stretch>
+        </p:blipFill>
+        <p:spPr>
+          <a:xfrm>
+            <a:off x="4142232" y="5705856"/>
+            <a:ext cx="274320" cy="274320"/>
+          </a:xfrm>
+          <a:prstGeom prst="rect">
+            <a:avLst/>
+          </a:prstGeom>
+        </p:spPr>
+      </p:pic>
+      <p:sp>
+        <p:nvSpPr>
+          <p:cNvPr id="38" name="Fix 4"/>
+          <p:cNvSpPr txBox="1"/>
+          <p:nvPr/>
+        </p:nvSpPr>
+        <p:spPr>
+          <a:xfrm>
+            <a:off x="4663440" y="5440680"/>
+            <a:ext cx="2395728" cy="804672"/>
+          </a:xfrm>
+          <a:prstGeom prst="rect">
+            <a:avLst/>
+          </a:prstGeom>
+          <a:noFill/>
+          <a:ln/>
+        </p:spPr>
+        <p:txBody>
+          <a:bodyPr wrap="square" lIns="0" tIns="0" rIns="0" bIns="0" rtlCol="0" anchor="ctr"/>
+          <a:lstStyle/>
+          <a:p>
+            <a:pPr indent="0" marL="0">
+              <a:spcAft>
+                <a:spcPts val="200"/>
+              </a:spcAft>
+              <a:buNone/>
+            </a:pPr>
+            <a:r>
+              <a:rPr lang="en-US" sz="1500" b="1" dirty="0">
+                <a:solidFill>
+                  <a:schemeClr val="tx1"/>
+                </a:solidFill>
+              </a:rPr>
+              <a:t>Usage insights</a:t>
+            </a:r>
+            <a:endParaRPr lang="en-US" sz="1500" dirty="0"/>
+          </a:p>
+          <a:p>
+            <a:pPr indent="0" marL="0">
+              <a:spcAft>
+                <a:spcPts val="200"/>
+              </a:spcAft>
+              <a:buNone/>
+            </a:pPr>
+            <a:r>
+              <a:rPr lang="en-US" sz="1400" dirty="0">
+                <a:solidFill>
+                  <a:schemeClr val="tx2"/>
+                </a:solidFill>
+              </a:rPr>
+              <a:t>Utilisation by zone and team, capacity outlook</a:t>
+            </a:r>
+            <a:endParaRPr lang="en-US" sz="1500" dirty="0"/>
+          </a:p>
+        </p:txBody>
+      </p:sp>
+      <p:sp>
+        <p:nvSpPr>
+          <p:cNvPr id="39" name="Screenshot frame"/>
+          <p:cNvSpPr/>
+          <p:nvPr/>
+        </p:nvSpPr>
+        <p:spPr>
+          <a:xfrm>
+            <a:off x="7452360" y="1783080"/>
+            <a:ext cx="4325112" cy="2737485"/>
+          </a:xfrm>
+          <a:prstGeom prst="roundRect">
+            <a:avLst>
+              <a:gd name="adj" fmla="val 2004"/>
             </a:avLst>
           </a:prstGeom>
           <a:solidFill>
@@ -1569,22 +2286,22 @@
       </p:sp>
       <p:pic>
         <p:nvPicPr>
-          <p:cNvPr id="18" name="Dashboard screenshot" descr="Admin dashboard: live floor plan coloured by project team, KPI cards and the colleague finder">    </p:cNvPr>
+          <p:cNvPr id="40" name="Dashboard screenshot" descr="Admin dashboard: live floor plan coloured by project team, KPI cards and the colleague finder">    </p:cNvPr>
           <p:cNvPicPr>
             <a:picLocks noChangeAspect="1"/>
           </p:cNvPicPr>
           <p:nvPr/>
         </p:nvPicPr>
         <p:blipFill>
-          <a:blip r:embed="rId6"/>
+          <a:blip r:embed="rId10"/>
           <a:stretch>
             <a:fillRect/>
           </a:stretch>
         </p:blipFill>
         <p:spPr>
           <a:xfrm>
-            <a:off x="5971032" y="1719072"/>
-            <a:ext cx="5760720" cy="3600450"/>
+            <a:off x="7498080" y="1828800"/>
+            <a:ext cx="4233672" cy="2646045"/>
           </a:xfrm>
           <a:prstGeom prst="rect">
             <a:avLst/>
@@ -1593,14 +2310,14 @@
       </p:pic>
       <p:sp>
         <p:nvSpPr>
-          <p:cNvPr id="19" name="Screenshot caption"/>
+          <p:cNvPr id="41" name="Screenshot caption"/>
           <p:cNvSpPr txBox="1"/>
           <p:nvPr/>
         </p:nvSpPr>
         <p:spPr>
           <a:xfrm>
-            <a:off x="5971032" y="5429250"/>
-            <a:ext cx="5760720" cy="256032"/>
+            <a:off x="7498080" y="4584573"/>
+            <a:ext cx="4233672" cy="237744"/>
           </a:xfrm>
           <a:prstGeom prst="rect">
             <a:avLst/>
@@ -1621,7 +2338,7 @@
                   <a:schemeClr val="tx2"/>
                 </a:solidFill>
               </a:rPr>
-              <a:t>Admin dashboard (demo data): live floor plan coloured by project team, with the colleague finder</a:t>
+              <a:t>Admin dashboard (demo data), coloured by project team</a:t>
             </a:r>
             <a:endParaRPr lang="en-US" sz="1100" dirty="0"/>
           </a:p>
@@ -1629,18 +2346,18 @@
       </p:sp>
       <p:sp>
         <p:nvSpPr>
-          <p:cNvPr id="20" name="Figure card 1"/>
+          <p:cNvPr id="42" name="Figure card 1"/>
           <p:cNvSpPr/>
           <p:nvPr/>
         </p:nvSpPr>
         <p:spPr>
           <a:xfrm>
-            <a:off x="457200" y="5870448"/>
-            <a:ext cx="2635758" cy="530352"/>
+            <a:off x="7498080" y="4873752"/>
+            <a:ext cx="2025396" cy="658368"/>
           </a:xfrm>
           <a:prstGeom prst="roundRect">
             <a:avLst>
-              <a:gd name="adj" fmla="val 13793"/>
+              <a:gd name="adj" fmla="val 11111"/>
             </a:avLst>
           </a:prstGeom>
           <a:solidFill>
@@ -1656,14 +2373,14 @@
       </p:sp>
       <p:sp>
         <p:nvSpPr>
-          <p:cNvPr id="21" name="Figure 1"/>
+          <p:cNvPr id="43" name="Figure 1"/>
           <p:cNvSpPr txBox="1"/>
           <p:nvPr/>
         </p:nvSpPr>
         <p:spPr>
           <a:xfrm>
-            <a:off x="640080" y="5870448"/>
-            <a:ext cx="2269998" cy="530352"/>
+            <a:off x="7662672" y="4873752"/>
+            <a:ext cx="1751076" cy="658368"/>
           </a:xfrm>
           <a:prstGeom prst="rect">
             <a:avLst/>
@@ -1679,42 +2396,45 @@
               <a:buNone/>
             </a:pPr>
             <a:r>
-              <a:rPr lang="en-US" sz="2400" b="1" dirty="0">
+              <a:rPr lang="en-US" sz="2200" b="1" dirty="0">
                 <a:solidFill>
                   <a:schemeClr val="accent1"/>
                 </a:solidFill>
               </a:rPr>
               <a:t>125</a:t>
             </a:r>
-            <a:pPr indent="0" marL="0">
-              <a:buNone/>
-            </a:pPr>
-            <a:r>
-              <a:rPr lang="en-US" sz="1400" dirty="0">
+            <a:endParaRPr lang="en-US" sz="2200" dirty="0"/>
+          </a:p>
+          <a:p>
+            <a:pPr indent="0" marL="0">
+              <a:buNone/>
+            </a:pPr>
+            <a:r>
+              <a:rPr lang="en-US" sz="1200" dirty="0">
                 <a:solidFill>
                   <a:schemeClr val="tx1"/>
                 </a:solidFill>
               </a:rPr>
-              <a:t>  desks on 2 floors</a:t>
-            </a:r>
-            <a:endParaRPr lang="en-US" sz="2400" dirty="0"/>
+              <a:t>desks on 2 floors</a:t>
+            </a:r>
+            <a:endParaRPr lang="en-US" sz="2200" dirty="0"/>
           </a:p>
         </p:txBody>
       </p:sp>
       <p:sp>
         <p:nvSpPr>
-          <p:cNvPr id="22" name="Figure card 2"/>
+          <p:cNvPr id="44" name="Figure card 2"/>
           <p:cNvSpPr/>
           <p:nvPr/>
         </p:nvSpPr>
         <p:spPr>
           <a:xfrm>
-            <a:off x="3275838" y="5870448"/>
-            <a:ext cx="2635758" cy="530352"/>
+            <a:off x="9706356" y="4873752"/>
+            <a:ext cx="2025396" cy="658368"/>
           </a:xfrm>
           <a:prstGeom prst="roundRect">
             <a:avLst>
-              <a:gd name="adj" fmla="val 13793"/>
+              <a:gd name="adj" fmla="val 11111"/>
             </a:avLst>
           </a:prstGeom>
           <a:solidFill>
@@ -1730,14 +2450,14 @@
       </p:sp>
       <p:sp>
         <p:nvSpPr>
-          <p:cNvPr id="23" name="Figure 2"/>
+          <p:cNvPr id="45" name="Figure 2"/>
           <p:cNvSpPr txBox="1"/>
           <p:nvPr/>
         </p:nvSpPr>
         <p:spPr>
           <a:xfrm>
-            <a:off x="3458718" y="5870448"/>
-            <a:ext cx="2269998" cy="530352"/>
+            <a:off x="9870948" y="4873752"/>
+            <a:ext cx="1751076" cy="658368"/>
           </a:xfrm>
           <a:prstGeom prst="rect">
             <a:avLst/>
@@ -1753,42 +2473,45 @@
               <a:buNone/>
             </a:pPr>
             <a:r>
-              <a:rPr lang="en-US" sz="2400" b="1" dirty="0">
+              <a:rPr lang="en-US" sz="2200" b="1" dirty="0">
                 <a:solidFill>
                   <a:schemeClr val="accent1"/>
                 </a:solidFill>
               </a:rPr>
               <a:t>8</a:t>
             </a:r>
-            <a:pPr indent="0" marL="0">
-              <a:buNone/>
-            </a:pPr>
-            <a:r>
-              <a:rPr lang="en-US" sz="1400" dirty="0">
+            <a:endParaRPr lang="en-US" sz="2200" dirty="0"/>
+          </a:p>
+          <a:p>
+            <a:pPr indent="0" marL="0">
+              <a:buNone/>
+            </a:pPr>
+            <a:r>
+              <a:rPr lang="en-US" sz="1200" dirty="0">
                 <a:solidFill>
                   <a:schemeClr val="tx1"/>
                 </a:solidFill>
               </a:rPr>
-              <a:t>  project teams</a:t>
-            </a:r>
-            <a:endParaRPr lang="en-US" sz="2400" dirty="0"/>
+              <a:t>project teams</a:t>
+            </a:r>
+            <a:endParaRPr lang="en-US" sz="2200" dirty="0"/>
           </a:p>
         </p:txBody>
       </p:sp>
       <p:sp>
         <p:nvSpPr>
-          <p:cNvPr id="24" name="Figure card 3"/>
+          <p:cNvPr id="46" name="Figure card 3"/>
           <p:cNvSpPr/>
           <p:nvPr/>
         </p:nvSpPr>
         <p:spPr>
           <a:xfrm>
-            <a:off x="6094476" y="5870448"/>
-            <a:ext cx="2635758" cy="530352"/>
+            <a:off x="7498080" y="5678424"/>
+            <a:ext cx="2025396" cy="658368"/>
           </a:xfrm>
           <a:prstGeom prst="roundRect">
             <a:avLst>
-              <a:gd name="adj" fmla="val 13793"/>
+              <a:gd name="adj" fmla="val 11111"/>
             </a:avLst>
           </a:prstGeom>
           <a:solidFill>
@@ -1804,14 +2527,14 @@
       </p:sp>
       <p:sp>
         <p:nvSpPr>
-          <p:cNvPr id="25" name="Figure 3"/>
+          <p:cNvPr id="47" name="Figure 3"/>
           <p:cNvSpPr txBox="1"/>
           <p:nvPr/>
         </p:nvSpPr>
         <p:spPr>
           <a:xfrm>
-            <a:off x="6277356" y="5870448"/>
-            <a:ext cx="2269998" cy="530352"/>
+            <a:off x="7662672" y="5678424"/>
+            <a:ext cx="1751076" cy="658368"/>
           </a:xfrm>
           <a:prstGeom prst="rect">
             <a:avLst/>
@@ -1827,42 +2550,45 @@
               <a:buNone/>
             </a:pPr>
             <a:r>
-              <a:rPr lang="en-US" sz="2400" b="1" dirty="0">
+              <a:rPr lang="en-US" sz="2200" b="1" dirty="0">
                 <a:solidFill>
                   <a:schemeClr val="accent1"/>
                 </a:solidFill>
               </a:rPr>
               <a:t>20 min</a:t>
             </a:r>
-            <a:pPr indent="0" marL="0">
-              <a:buNone/>
-            </a:pPr>
-            <a:r>
-              <a:rPr lang="en-US" sz="1400" dirty="0">
+            <a:endParaRPr lang="en-US" sz="2200" dirty="0"/>
+          </a:p>
+          <a:p>
+            <a:pPr indent="0" marL="0">
+              <a:buNone/>
+            </a:pPr>
+            <a:r>
+              <a:rPr lang="en-US" sz="1200" dirty="0">
                 <a:solidFill>
                   <a:schemeClr val="tx1"/>
                 </a:solidFill>
               </a:rPr>
-              <a:t>  auto-release</a:t>
-            </a:r>
-            <a:endParaRPr lang="en-US" sz="2400" dirty="0"/>
+              <a:t>to free an empty desk</a:t>
+            </a:r>
+            <a:endParaRPr lang="en-US" sz="2200" dirty="0"/>
           </a:p>
         </p:txBody>
       </p:sp>
       <p:sp>
         <p:nvSpPr>
-          <p:cNvPr id="26" name="Figure card 4"/>
+          <p:cNvPr id="48" name="Figure card 4"/>
           <p:cNvSpPr/>
           <p:nvPr/>
         </p:nvSpPr>
         <p:spPr>
           <a:xfrm>
-            <a:off x="8913114" y="5870448"/>
-            <a:ext cx="2635758" cy="530352"/>
+            <a:off x="9706356" y="5678424"/>
+            <a:ext cx="2025396" cy="658368"/>
           </a:xfrm>
           <a:prstGeom prst="roundRect">
             <a:avLst>
-              <a:gd name="adj" fmla="val 13793"/>
+              <a:gd name="adj" fmla="val 11111"/>
             </a:avLst>
           </a:prstGeom>
           <a:solidFill>
@@ -1878,14 +2604,14 @@
       </p:sp>
       <p:sp>
         <p:nvSpPr>
-          <p:cNvPr id="27" name="Figure 4"/>
+          <p:cNvPr id="49" name="Figure 4"/>
           <p:cNvSpPr txBox="1"/>
           <p:nvPr/>
         </p:nvSpPr>
         <p:spPr>
           <a:xfrm>
-            <a:off x="9095994" y="5870448"/>
-            <a:ext cx="2269998" cy="530352"/>
+            <a:off x="9870948" y="5678424"/>
+            <a:ext cx="1751076" cy="658368"/>
           </a:xfrm>
           <a:prstGeom prst="rect">
             <a:avLst/>
@@ -1901,25 +2627,28 @@
               <a:buNone/>
             </a:pPr>
             <a:r>
-              <a:rPr lang="en-US" sz="2400" b="1" dirty="0">
+              <a:rPr lang="en-US" sz="2200" b="1" dirty="0">
                 <a:solidFill>
                   <a:schemeClr val="accent1"/>
                 </a:solidFill>
               </a:rPr>
               <a:t>3 h</a:t>
             </a:r>
-            <a:pPr indent="0" marL="0">
-              <a:buNone/>
-            </a:pPr>
-            <a:r>
-              <a:rPr lang="en-US" sz="1400" dirty="0">
+            <a:endParaRPr lang="en-US" sz="2200" dirty="0"/>
+          </a:p>
+          <a:p>
+            <a:pPr indent="0" marL="0">
+              <a:buNone/>
+            </a:pPr>
+            <a:r>
+              <a:rPr lang="en-US" sz="1200" dirty="0">
                 <a:solidFill>
                   <a:schemeClr val="tx1"/>
                 </a:solidFill>
               </a:rPr>
-              <a:t>  default check-in</a:t>
-            </a:r>
-            <a:endParaRPr lang="en-US" sz="2400" dirty="0"/>
+              <a:t>default check-in</a:t>
+            </a:r>
+            <a:endParaRPr lang="en-US" sz="2200" dirty="0"/>
           </a:p>
         </p:txBody>
       </p:sp>
@@ -1963,7 +2692,7 @@
         <a:srgbClr val="7C3AED"/>
       </a:accent5>
       <a:accent6>
-        <a:srgbClr val="DC2626"/>
+        <a:srgbClr val="C2410C"/>
       </a:accent6>
       <a:hlink>
         <a:srgbClr val="2563EB"/>

</xml_diff>

<commit_message>
Project slides: add a cartoon-strip introduction
New first slide, 'Hot desking today: the daily desk hunt': a four-panel
comic of project teams who can't find seats (desks claimed by bags and
jackets), one zone crowded while another sits empty, and teammates
scattered across floors; captions, a takeaway line and speaker notes.
The pain -> fix slide follows as slide 2.

Co-Authored-By: Claude Opus 5.5 <noreply@anthropic.com>
Claude-Session: https://claude.ai/code/session_01R5PsyFbuq2Dda7FuaF5nhy
</commit_message>
<xml_diff>
--- a/docs/Hot-Desk-Monitor.pptx
+++ b/docs/Hot-Desk-Monitor.pptx
@@ -6,9 +6,10 @@
   </p:sldMasterIdLst>
   <p:sldIdLst>
     <p:sldId id="256" r:id="rId2"/>
+    <p:sldId id="257" r:id="rId3"/>
   </p:sldIdLst>
   <p:notesMasterIdLst>
-    <p:notesMasterId r:id="rId3"/>
+    <p:notesMasterId r:id="rId4"/>
   </p:notesMasterIdLst>
   <p:sldSz cx="12192000" cy="6858000"/>
   <p:notesSz cx="6858000" cy="12192000"/>
@@ -107,9 +108,14 @@
   <p:extLst>
     <p:ext uri="{521415D9-36F7-43E2-AB2F-B90AF26B5E84}">
       <p14:sectionLst xmlns:p14="http://schemas.microsoft.com/office/powerpoint/2010/main">
-        <p14:section name="Overview" id="{cc1d1ca6-3d57-cb3e-40e3-e8c82a031ea6}">
+        <p14:section name="Introduction" id="{66c6bf59-04c5-ac98-43a1-7c0b860f20e8}">
           <p14:sldIdLst>
             <p14:sldId id="256"/>
+          </p14:sldIdLst>
+        </p14:section>
+        <p14:section name="Overview" id="{6a14ce3c-00c7-0d1f-d2f6-4c6d14938488}">
+          <p14:sldIdLst>
+            <p14:sldId id="257"/>
           </p14:sldIdLst>
         </p14:section>
       </p14:sectionLst>
@@ -516,12 +522,12 @@
           <a:p>
             <a:r>
               <a:rPr lang="en-US" dirty="0"/>
-              <a:t>Hot desking only works if people can find a free desk quickly and desks are not blocked by people who are not using them. Hot Desk Monitor tackles four pains.
-1. Hunting for a free desk: instead of walking the floors, people see free desks on the live floor plan, on the office wall display, or on their phone.
-2. Ghost desks: desks held by a bag, or booked and never used. Under-desk sensors see when someone leaves; the desk frees itself 20 minutes later. Reservations nobody checks in to are released 30 minutes after the slot starts, and check-ins expire unless renewed.
-3. Teams scattered: occupied desks are coloured by project team, team leads can book several seats together, projects can have pre-allocated seats, and the colleague finder shows who is in and where.
-4. Guesswork on space: the dashboard shows utilisation by zone and project team, and the Insights page gives a capacity outlook (currently on simulated data until real sensor data builds up).
-Key figures: 125 desks on 2 floors at DIC Annex, 8 project teams, 20 minutes to free an empty desk, 3-hour default check-in. It deploys to AWS from GitHub and can be demoed in GitHub Codespaces.</a:t>
+              <a:t>Before the solution, a typical morning at DIC Annex.
+9:05: someone arrives and every desk looks taken, but it is a bag, a jacket or a sticky note; nobody is actually sitting there.
+Crowded: one zone, here the Digital Factory, is packed because teams squeeze in where they always sit; latecomers from the same project have nowhere to go.
+Empty: at the same time another zone, here the AI Lab, is almost empty, a short walk away, but nobody knows.
+Scattered: teammates end up on different floors and spend time on the phone working out where everyone is.
+The cost: time lost every morning, teams kept apart, and space that is crowded in one place and empty in another. Next slide: how Hot Desk Monitor fixes each of these.</a:t>
             </a:r>
             <a:endParaRPr lang="en-US" dirty="0"/>
           </a:p>
@@ -545,6 +551,99 @@
             <a:fld id="{F7021451-1387-4CA6-816F-3879F97B5CBC}" type="slidenum">
               <a:rPr lang="en-US"/>
               <a:t>1</a:t>
+            </a:fld>
+            <a:endParaRPr lang="en-US"/>
+          </a:p>
+        </p:txBody>
+      </p:sp>
+    </p:spTree>
+    <p:extLst>
+      <p:ext uri="{BB962C8B-B14F-4D97-AF65-F5344CB8AC3E}">
+        <p14:creationId xmlns:p14="http://schemas.microsoft.com/office/powerpoint/2010/main" val="1024086991"/>
+      </p:ext>
+    </p:extLst>
+  </p:cSld>
+  <p:clrMapOvr>
+    <a:masterClrMapping/>
+  </p:clrMapOvr>
+</p:notes>
+</file>
+
+<file path=ppt/notesSlides/notesSlide2.xml><?xml version="1.0" encoding="utf-8"?>
+<p:notes xmlns:a="http://schemas.openxmlformats.org/drawingml/2006/main" xmlns:r="http://schemas.openxmlformats.org/officeDocument/2006/relationships" xmlns:p="http://schemas.openxmlformats.org/presentationml/2006/main">
+  <p:cSld>
+    <p:spTree>
+      <p:nvGrpSpPr>
+        <p:cNvPr id="1" name=""/>
+        <p:cNvGrpSpPr/>
+        <p:nvPr/>
+      </p:nvGrpSpPr>
+      <p:grpSpPr>
+        <a:xfrm>
+          <a:off x="0" y="0"/>
+          <a:ext cx="0" cy="0"/>
+          <a:chOff x="0" y="0"/>
+          <a:chExt cx="0" cy="0"/>
+        </a:xfrm>
+      </p:grpSpPr>
+      <p:sp>
+        <p:nvSpPr>
+          <p:cNvPr id="2" name="Slide Image Placeholder 1"/>
+          <p:cNvSpPr>
+            <a:spLocks noGrp="1" noRot="1" noChangeAspect="1"/>
+          </p:cNvSpPr>
+          <p:nvPr>
+            <p:ph type="sldImg"/>
+          </p:nvPr>
+        </p:nvSpPr>
+        <p:spPr/>
+      </p:sp>
+      <p:sp>
+        <p:nvSpPr>
+          <p:cNvPr id="3" name="Notes Placeholder 2"/>
+          <p:cNvSpPr>
+            <a:spLocks noGrp="1"/>
+          </p:cNvSpPr>
+          <p:nvPr>
+            <p:ph type="body" idx="1"/>
+          </p:nvPr>
+        </p:nvSpPr>
+        <p:spPr/>
+        <p:txBody>
+          <a:bodyPr/>
+          <a:lstStyle/>
+          <a:p>
+            <a:r>
+              <a:rPr lang="en-US" dirty="0"/>
+              <a:t>Hot desking only works if people can find a free desk quickly and desks are not blocked by people who are not using them. Hot Desk Monitor tackles four pains.
+1. Hunting for a free desk: instead of walking the floors, people see free desks on the live floor plan, on the office wall display, or on their phone.
+2. Ghost desks: desks held by a bag, or booked and never used. Under-desk sensors see when someone leaves; the desk frees itself 20 minutes later. Reservations nobody checks in to are released 30 minutes after the slot starts, and check-ins expire unless renewed.
+3. Teams scattered: occupied desks are coloured by project team, team leads can book several seats together, projects can have pre-allocated seats, and the colleague finder shows who is in and where.
+4. Guesswork on space: the dashboard shows utilisation by zone and project team, and the Insights page gives a capacity outlook (currently on simulated data until real sensor data builds up).
+Key figures: 125 desks on 2 floors at DIC Annex, 8 project teams, 20 minutes to free an empty desk, 3-hour default check-in. It deploys to AWS from GitHub and can be demoed in GitHub Codespaces.</a:t>
+            </a:r>
+            <a:endParaRPr lang="en-US" dirty="0"/>
+          </a:p>
+        </p:txBody>
+      </p:sp>
+      <p:sp>
+        <p:nvSpPr>
+          <p:cNvPr id="4" name="Slide Number Placeholder 3"/>
+          <p:cNvSpPr>
+            <a:spLocks noGrp="1"/>
+          </p:cNvSpPr>
+          <p:nvPr>
+            <p:ph type="sldNum" sz="quarter" idx="10"/>
+          </p:nvPr>
+        </p:nvSpPr>
+        <p:spPr/>
+        <p:txBody>
+          <a:bodyPr/>
+          <a:lstStyle/>
+          <a:p>
+            <a:fld id="{F7021451-1387-4CA6-816F-3879F97B5CBC}" type="slidenum">
+              <a:rPr lang="en-US"/>
+              <a:t>2</a:t>
             </a:fld>
             <a:endParaRPr lang="en-US"/>
           </a:p>
@@ -1000,6 +1099,449 @@
 <file path=ppt/slides/slide1.xml><?xml version="1.0" encoding="utf-8"?>
 <p:sld xmlns:a="http://schemas.openxmlformats.org/drawingml/2006/main" xmlns:r="http://schemas.openxmlformats.org/officeDocument/2006/relationships" xmlns:p="http://schemas.openxmlformats.org/presentationml/2006/main">
   <p:cSld name="Slide 1">
+    <p:spTree>
+      <p:nvGrpSpPr>
+        <p:cNvPr id="1" name=""/>
+        <p:cNvGrpSpPr/>
+        <p:nvPr/>
+      </p:nvGrpSpPr>
+      <p:grpSpPr>
+        <a:xfrm>
+          <a:off x="0" y="0"/>
+          <a:ext cx="0" cy="0"/>
+          <a:chOff x="0" y="0"/>
+          <a:chExt cx="0" cy="0"/>
+        </a:xfrm>
+      </p:grpSpPr>
+      <p:pic>
+        <p:nvPicPr>
+          <p:cNvPr id="2" name="Logo" descr="Hot Desk logo">    </p:cNvPr>
+          <p:cNvPicPr>
+            <a:picLocks noChangeAspect="1"/>
+          </p:cNvPicPr>
+          <p:nvPr/>
+        </p:nvPicPr>
+        <p:blipFill>
+          <a:blip r:embed="rId1"/>
+          <a:stretch>
+            <a:fillRect/>
+          </a:stretch>
+        </p:blipFill>
+        <p:spPr>
+          <a:xfrm>
+            <a:off x="457200" y="411480"/>
+            <a:ext cx="566928" cy="566928"/>
+          </a:xfrm>
+          <a:prstGeom prst="rect">
+            <a:avLst/>
+          </a:prstGeom>
+        </p:spPr>
+      </p:pic>
+      <p:sp>
+        <p:nvSpPr>
+          <p:cNvPr id="3" name="Text 0"/>
+          <p:cNvSpPr/>
+          <p:nvPr>
+            <p:ph idx="100" type="title" hasCustomPrompt="1"/>
+          </p:nvPr>
+        </p:nvSpPr>
+        <p:spPr>
+          <a:xfrm>
+            <a:off x="1234440" y="384048"/>
+            <a:ext cx="10469880" cy="566928"/>
+          </a:xfrm>
+          <a:prstGeom prst="rect">
+            <a:avLst/>
+          </a:prstGeom>
+          <a:noFill/>
+          <a:ln/>
+        </p:spPr>
+        <p:txBody>
+          <a:bodyPr wrap="square" lIns="0" tIns="0" rIns="0" bIns="0" rtlCol="0" anchor="ctr"/>
+          <a:lstStyle/>
+          <a:p>
+            <a:pPr indent="0" marL="0">
+              <a:buNone/>
+            </a:pPr>
+            <a:r>
+              <a:rPr lang="en-US" sz="3000" b="1" dirty="0">
+                <a:solidFill>
+                  <a:schemeClr val="tx1"/>
+                </a:solidFill>
+              </a:rPr>
+              <a:t>Hot desking today: the daily desk hunt</a:t>
+            </a:r>
+            <a:endParaRPr lang="en-US" sz="3000" dirty="0"/>
+          </a:p>
+        </p:txBody>
+      </p:sp>
+      <p:sp>
+        <p:nvSpPr>
+          <p:cNvPr id="4" name="Text 0"/>
+          <p:cNvSpPr/>
+          <p:nvPr>
+            <p:ph idx="101" type="body" hasCustomPrompt="1"/>
+          </p:nvPr>
+        </p:nvSpPr>
+        <p:spPr>
+          <a:xfrm>
+            <a:off x="1234440" y="987552"/>
+            <a:ext cx="10469880" cy="566928"/>
+          </a:xfrm>
+          <a:prstGeom prst="rect">
+            <a:avLst/>
+          </a:prstGeom>
+          <a:noFill/>
+          <a:ln/>
+        </p:spPr>
+        <p:txBody>
+          <a:bodyPr wrap="square" lIns="0" tIns="0" rIns="0" bIns="0" rtlCol="0" anchor="t"/>
+          <a:lstStyle/>
+          <a:p>
+            <a:pPr indent="0" marL="0">
+              <a:buNone/>
+            </a:pPr>
+            <a:r>
+              <a:rPr lang="en-US" sz="1600" dirty="0">
+                <a:solidFill>
+                  <a:schemeClr val="tx2"/>
+                </a:solidFill>
+              </a:rPr>
+              <a:t>What our project teams run into at DIC Annex when nobody can see which desks are really free.</a:t>
+            </a:r>
+            <a:endParaRPr lang="en-US" sz="1600" dirty="0"/>
+          </a:p>
+        </p:txBody>
+      </p:sp>
+      <p:pic>
+        <p:nvPicPr>
+          <p:cNvPr id="5" name="Cartoon panel 1" descr="Panel 1, 9:05 AM: a worried SAP team member with a laptop walks past desks claimed by a bag, a jacket and a &quot;Mine!&quot; sticky note, thinking &quot;Every desk is taken…?&quot;">    </p:cNvPr>
+          <p:cNvPicPr>
+            <a:picLocks noChangeAspect="1"/>
+          </p:cNvPicPr>
+          <p:nvPr/>
+        </p:nvPicPr>
+        <p:blipFill>
+          <a:blip r:embed="rId2"/>
+          <a:stretch>
+            <a:fillRect/>
+          </a:stretch>
+        </p:blipFill>
+        <p:spPr>
+          <a:xfrm>
+            <a:off x="457200" y="1691640"/>
+            <a:ext cx="2670048" cy="3115056"/>
+          </a:xfrm>
+          <a:prstGeom prst="rect">
+            <a:avLst/>
+          </a:prstGeom>
+        </p:spPr>
+      </p:pic>
+      <p:sp>
+        <p:nvSpPr>
+          <p:cNvPr id="6" name="Panel caption 1"/>
+          <p:cNvSpPr txBox="1"/>
+          <p:nvPr/>
+        </p:nvSpPr>
+        <p:spPr>
+          <a:xfrm>
+            <a:off x="457200" y="4934712"/>
+            <a:ext cx="2670048" cy="685800"/>
+          </a:xfrm>
+          <a:prstGeom prst="rect">
+            <a:avLst/>
+          </a:prstGeom>
+          <a:noFill/>
+          <a:ln/>
+        </p:spPr>
+        <p:txBody>
+          <a:bodyPr wrap="square" lIns="0" tIns="0" rIns="0" bIns="0" rtlCol="0" anchor="t"/>
+          <a:lstStyle/>
+          <a:p>
+            <a:pPr indent="0" marL="0">
+              <a:buNone/>
+            </a:pPr>
+            <a:r>
+              <a:rPr lang="en-US" sz="1400" dirty="0">
+                <a:solidFill>
+                  <a:schemeClr val="tx1"/>
+                </a:solidFill>
+              </a:rPr>
+              <a:t>Desks look taken (a bag here, a jacket there) but nobody is sitting at them.</a:t>
+            </a:r>
+            <a:endParaRPr lang="en-US" sz="1400" dirty="0"/>
+          </a:p>
+        </p:txBody>
+      </p:sp>
+      <p:pic>
+        <p:nvPicPr>
+          <p:cNvPr id="7" name="Cartoon panel 2" descr="Panel 2, Crowded: the Digital Factory is full, two people stand waiting, and an SAP team member throws up their arms: &quot;No seat for SAP!&quot;">    </p:cNvPr>
+          <p:cNvPicPr>
+            <a:picLocks noChangeAspect="1"/>
+          </p:cNvPicPr>
+          <p:nvPr/>
+        </p:nvPicPr>
+        <p:blipFill>
+          <a:blip r:embed="rId3"/>
+          <a:stretch>
+            <a:fillRect/>
+          </a:stretch>
+        </p:blipFill>
+        <p:spPr>
+          <a:xfrm>
+            <a:off x="3325368" y="1691640"/>
+            <a:ext cx="2670048" cy="3115056"/>
+          </a:xfrm>
+          <a:prstGeom prst="rect">
+            <a:avLst/>
+          </a:prstGeom>
+        </p:spPr>
+      </p:pic>
+      <p:sp>
+        <p:nvSpPr>
+          <p:cNvPr id="8" name="Panel caption 2"/>
+          <p:cNvSpPr txBox="1"/>
+          <p:nvPr/>
+        </p:nvSpPr>
+        <p:spPr>
+          <a:xfrm>
+            <a:off x="3325368" y="4934712"/>
+            <a:ext cx="2670048" cy="685800"/>
+          </a:xfrm>
+          <a:prstGeom prst="rect">
+            <a:avLst/>
+          </a:prstGeom>
+          <a:noFill/>
+          <a:ln/>
+        </p:spPr>
+        <p:txBody>
+          <a:bodyPr wrap="square" lIns="0" tIns="0" rIns="0" bIns="0" rtlCol="0" anchor="t"/>
+          <a:lstStyle/>
+          <a:p>
+            <a:pPr indent="0" marL="0">
+              <a:buNone/>
+            </a:pPr>
+            <a:r>
+              <a:rPr lang="en-US" sz="1400" dirty="0">
+                <a:solidFill>
+                  <a:schemeClr val="tx1"/>
+                </a:solidFill>
+              </a:rPr>
+              <a:t>One zone is packed, and teammates who arrive later have nowhere to sit.</a:t>
+            </a:r>
+            <a:endParaRPr lang="en-US" sz="1400" dirty="0"/>
+          </a:p>
+        </p:txBody>
+      </p:sp>
+      <p:pic>
+        <p:nvPicPr>
+          <p:cNvPr id="9" name="Cartoon panel 3" descr="Panel 3, …and empty: the AI Lab has empty desks, a cobweb, a plant and a tumbleweed rolling past, with only &quot;chirp… chirp…&quot;">    </p:cNvPr>
+          <p:cNvPicPr>
+            <a:picLocks noChangeAspect="1"/>
+          </p:cNvPicPr>
+          <p:nvPr/>
+        </p:nvPicPr>
+        <p:blipFill>
+          <a:blip r:embed="rId4"/>
+          <a:stretch>
+            <a:fillRect/>
+          </a:stretch>
+        </p:blipFill>
+        <p:spPr>
+          <a:xfrm>
+            <a:off x="6193536" y="1691640"/>
+            <a:ext cx="2670048" cy="3115056"/>
+          </a:xfrm>
+          <a:prstGeom prst="rect">
+            <a:avLst/>
+          </a:prstGeom>
+        </p:spPr>
+      </p:pic>
+      <p:sp>
+        <p:nvSpPr>
+          <p:cNvPr id="10" name="Panel caption 3"/>
+          <p:cNvSpPr txBox="1"/>
+          <p:nvPr/>
+        </p:nvSpPr>
+        <p:spPr>
+          <a:xfrm>
+            <a:off x="6193536" y="4934712"/>
+            <a:ext cx="2670048" cy="685800"/>
+          </a:xfrm>
+          <a:prstGeom prst="rect">
+            <a:avLst/>
+          </a:prstGeom>
+          <a:noFill/>
+          <a:ln/>
+        </p:spPr>
+        <p:txBody>
+          <a:bodyPr wrap="square" lIns="0" tIns="0" rIns="0" bIns="0" rtlCol="0" anchor="t"/>
+          <a:lstStyle/>
+          <a:p>
+            <a:pPr indent="0" marL="0">
+              <a:buNone/>
+            </a:pPr>
+            <a:r>
+              <a:rPr lang="en-US" sz="1400" dirty="0">
+                <a:solidFill>
+                  <a:schemeClr val="tx1"/>
+                </a:solidFill>
+              </a:rPr>
+              <a:t>Meanwhile another zone sits empty, a short walk away.</a:t>
+            </a:r>
+            <a:endParaRPr lang="en-US" sz="1400" dirty="0"/>
+          </a:p>
+        </p:txBody>
+      </p:sp>
+      <p:pic>
+        <p:nvPicPr>
+          <p:cNvPr id="11" name="Cartoon panel 4" descr="Panel 4, Scattered: two External team members on the phone on different floors: &quot;Where's the team today?&quot; &quot;No idea, I just got here!&quot;">    </p:cNvPr>
+          <p:cNvPicPr>
+            <a:picLocks noChangeAspect="1"/>
+          </p:cNvPicPr>
+          <p:nvPr/>
+        </p:nvPicPr>
+        <p:blipFill>
+          <a:blip r:embed="rId5"/>
+          <a:stretch>
+            <a:fillRect/>
+          </a:stretch>
+        </p:blipFill>
+        <p:spPr>
+          <a:xfrm>
+            <a:off x="9061704" y="1691640"/>
+            <a:ext cx="2670048" cy="3115056"/>
+          </a:xfrm>
+          <a:prstGeom prst="rect">
+            <a:avLst/>
+          </a:prstGeom>
+        </p:spPr>
+      </p:pic>
+      <p:sp>
+        <p:nvSpPr>
+          <p:cNvPr id="12" name="Panel caption 4"/>
+          <p:cNvSpPr txBox="1"/>
+          <p:nvPr/>
+        </p:nvSpPr>
+        <p:spPr>
+          <a:xfrm>
+            <a:off x="9061704" y="4934712"/>
+            <a:ext cx="2670048" cy="685800"/>
+          </a:xfrm>
+          <a:prstGeom prst="rect">
+            <a:avLst/>
+          </a:prstGeom>
+          <a:noFill/>
+          <a:ln/>
+        </p:spPr>
+        <p:txBody>
+          <a:bodyPr wrap="square" lIns="0" tIns="0" rIns="0" bIns="0" rtlCol="0" anchor="t"/>
+          <a:lstStyle/>
+          <a:p>
+            <a:pPr indent="0" marL="0">
+              <a:buNone/>
+            </a:pPr>
+            <a:r>
+              <a:rPr lang="en-US" sz="1400" dirty="0">
+                <a:solidFill>
+                  <a:schemeClr val="tx1"/>
+                </a:solidFill>
+              </a:rPr>
+              <a:t>Teammates end up scattered and can’t find each other.</a:t>
+            </a:r>
+            <a:endParaRPr lang="en-US" sz="1400" dirty="0"/>
+          </a:p>
+        </p:txBody>
+      </p:sp>
+      <p:sp>
+        <p:nvSpPr>
+          <p:cNvPr id="13" name="Takeaway card"/>
+          <p:cNvSpPr/>
+          <p:nvPr/>
+        </p:nvSpPr>
+        <p:spPr>
+          <a:xfrm>
+            <a:off x="457200" y="5760720"/>
+            <a:ext cx="11274552" cy="603504"/>
+          </a:xfrm>
+          <a:prstGeom prst="roundRect">
+            <a:avLst>
+              <a:gd name="adj" fmla="val 15152"/>
+            </a:avLst>
+          </a:prstGeom>
+          <a:solidFill>
+            <a:schemeClr val="accent6">
+              <a:alpha val="12000"/>
+            </a:schemeClr>
+          </a:solidFill>
+          <a:ln w="12700">
+            <a:solidFill>
+              <a:schemeClr val="accent6">
+                <a:alpha val="12000"/>
+              </a:schemeClr>
+            </a:solidFill>
+            <a:prstDash val="solid"/>
+          </a:ln>
+        </p:spPr>
+      </p:sp>
+      <p:sp>
+        <p:nvSpPr>
+          <p:cNvPr id="14" name="Takeaway"/>
+          <p:cNvSpPr txBox="1"/>
+          <p:nvPr/>
+        </p:nvSpPr>
+        <p:spPr>
+          <a:xfrm>
+            <a:off x="685800" y="5760720"/>
+            <a:ext cx="10835640" cy="603504"/>
+          </a:xfrm>
+          <a:prstGeom prst="rect">
+            <a:avLst/>
+          </a:prstGeom>
+          <a:noFill/>
+          <a:ln/>
+        </p:spPr>
+        <p:txBody>
+          <a:bodyPr wrap="square" lIns="0" tIns="0" rIns="0" bIns="0" rtlCol="0" anchor="ctr"/>
+          <a:lstStyle/>
+          <a:p>
+            <a:pPr indent="0" marL="0">
+              <a:buNone/>
+            </a:pPr>
+            <a:r>
+              <a:rPr lang="en-US" sz="1600" b="1" dirty="0">
+                <a:solidFill>
+                  <a:schemeClr val="accent6"/>
+                </a:solidFill>
+              </a:rPr>
+              <a:t>The cost: </a:t>
+            </a:r>
+            <a:pPr indent="0" marL="0">
+              <a:buNone/>
+            </a:pPr>
+            <a:r>
+              <a:rPr lang="en-US" sz="1600" dirty="0">
+                <a:solidFill>
+                  <a:schemeClr val="tx1"/>
+                </a:solidFill>
+              </a:rPr>
+              <a:t>time lost hunting for desks, teams kept apart, and space crowded in one zone while another sits empty.</a:t>
+            </a:r>
+            <a:endParaRPr lang="en-US" sz="1600" dirty="0"/>
+          </a:p>
+        </p:txBody>
+      </p:sp>
+    </p:spTree>
+  </p:cSld>
+  <p:clrMapOvr>
+    <a:masterClrMapping/>
+  </p:clrMapOvr>
+</p:sld>
+</file>
+
+<file path=ppt/slides/slide2.xml><?xml version="1.0" encoding="utf-8"?>
+<p:sld xmlns:a="http://schemas.openxmlformats.org/drawingml/2006/main" xmlns:r="http://schemas.openxmlformats.org/officeDocument/2006/relationships" xmlns:p="http://schemas.openxmlformats.org/presentationml/2006/main">
+  <p:cSld name="Slide 2">
     <p:spTree>
       <p:nvGrpSpPr>
         <p:cNvPr id="1" name=""/>

</xml_diff>

<commit_message>
Project slides: add the new-team seat request pain point
Slide 2 gets a fifth pain -> fix row: a new project team asks for seats
and the administrator can't tell if the floor can take them -> the
Insights what-if planner (add their headcount, see if seats run out).
'Usage insights' now covers utilisation and busiest days so the rows
don't overlap. Speaker notes updated, noting Insights run on simulated
data for now.

Co-Authored-By: Claude Opus 5.5 <noreply@anthropic.com>
Claude-Session: https://claude.ai/code/session_01R5PsyFbuq2Dda7FuaF5nhy
</commit_message>
<xml_diff>
--- a/docs/Hot-Desk-Monitor.pptx
+++ b/docs/Hot-Desk-Monitor.pptx
@@ -108,12 +108,12 @@
   <p:extLst>
     <p:ext uri="{521415D9-36F7-43E2-AB2F-B90AF26B5E84}">
       <p14:sectionLst xmlns:p14="http://schemas.microsoft.com/office/powerpoint/2010/main">
-        <p14:section name="Introduction" id="{66c6bf59-04c5-ac98-43a1-7c0b860f20e8}">
+        <p14:section name="Introduction" id="{ac0e7d49-511a-662b-d0e2-14fcdb6064ac}">
           <p14:sldIdLst>
             <p14:sldId id="256"/>
           </p14:sldIdLst>
         </p14:section>
-        <p14:section name="Overview" id="{6a14ce3c-00c7-0d1f-d2f6-4c6d14938488}">
+        <p14:section name="Overview" id="{2b53a16f-ac02-20f3-ff92-f61b1ab51aca}">
           <p14:sldIdLst>
             <p14:sldId id="257"/>
           </p14:sldIdLst>
@@ -615,11 +615,12 @@
           <a:p>
             <a:r>
               <a:rPr lang="en-US" dirty="0"/>
-              <a:t>Hot desking only works if people can find a free desk quickly and desks are not blocked by people who are not using them. Hot Desk Monitor tackles four pains.
+              <a:t>Hot desking only works if people can find a free desk quickly and desks are not blocked by people who are not using them. Hot Desk Monitor tackles five pains.
 1. Hunting for a free desk: instead of walking the floors, people see free desks on the live floor plan, on the office wall display, or on their phone.
 2. Ghost desks: desks held by a bag, or booked and never used. Under-desk sensors see when someone leaves; the desk frees itself 20 minutes later. Reservations nobody checks in to are released 30 minutes after the slot starts, and check-ins expire unless renewed.
 3. Teams scattered: occupied desks are coloured by project team, team leads can book several seats together, projects can have pre-allocated seats, and the colleague finder shows who is in and where.
-4. Guesswork on space: the dashboard shows utilisation by zone and project team, and the Insights page gives a capacity outlook (currently on simulated data until real sensor data builds up).
+4. Guesswork on space: the dashboard shows utilisation by zone and project team, and the busiest days.
+5. A new project team asks for seats, and the administrator cannot tell whether the floor can take them. The Insights page has a what-if planner: add the new team's headcount (or change the seats) and it shows how many people would be left without a seat on busy days and how many seats are needed, alongside a capacity outlook. Insights currently run on simulated data until real sensor and check-in data builds up.
 Key figures: 125 desks on 2 floors at DIC Annex, 8 project teams, 20 minutes to free an empty desk, 3-hour default check-in. It deploys to AWS from GitHub and can be demoed in GitHub Codespaces.</a:t>
             </a:r>
             <a:endParaRPr lang="en-US" dirty="0"/>
@@ -1737,11 +1738,11 @@
         <p:spPr>
           <a:xfrm>
             <a:off x="457200" y="2057400"/>
-            <a:ext cx="6720840" cy="987552"/>
+            <a:ext cx="6720840" cy="786384"/>
           </a:xfrm>
           <a:prstGeom prst="roundRect">
             <a:avLst>
-              <a:gd name="adj" fmla="val 9259"/>
+              <a:gd name="adj" fmla="val 11628"/>
             </a:avLst>
           </a:prstGeom>
           <a:solidFill>
@@ -1763,7 +1764,7 @@
         </p:nvSpPr>
         <p:spPr>
           <a:xfrm>
-            <a:off x="621792" y="2313432"/>
+            <a:off x="621792" y="2212848"/>
             <a:ext cx="475488" cy="475488"/>
           </a:xfrm>
           <a:prstGeom prst="ellipse">
@@ -1800,7 +1801,7 @@
         </p:blipFill>
         <p:spPr>
           <a:xfrm>
-            <a:off x="722376" y="2414016"/>
+            <a:off x="722376" y="2313432"/>
             <a:ext cx="274320" cy="274320"/>
           </a:xfrm>
           <a:prstGeom prst="rect">
@@ -1816,8 +1817,8 @@
         </p:nvSpPr>
         <p:spPr>
           <a:xfrm>
-            <a:off x="1243584" y="2148840"/>
-            <a:ext cx="2240280" cy="804672"/>
+            <a:off x="1243584" y="2103120"/>
+            <a:ext cx="2240280" cy="694944"/>
           </a:xfrm>
           <a:prstGeom prst="rect">
             <a:avLst/>
@@ -1831,7 +1832,7 @@
           <a:p>
             <a:pPr indent="0" marL="0">
               <a:spcAft>
-                <a:spcPts val="200"/>
+                <a:spcPts val="100"/>
               </a:spcAft>
               <a:buNone/>
             </a:pPr>
@@ -1848,7 +1849,7 @@
           <a:p>
             <a:pPr indent="0" marL="0">
               <a:spcAft>
-                <a:spcPts val="200"/>
+                <a:spcPts val="100"/>
               </a:spcAft>
               <a:buNone/>
             </a:pPr>
@@ -1872,7 +1873,7 @@
         </p:nvSpPr>
         <p:spPr>
           <a:xfrm>
-            <a:off x="3593592" y="2441448"/>
+            <a:off x="3593592" y="2340864"/>
             <a:ext cx="292608" cy="219456"/>
           </a:xfrm>
           <a:prstGeom prst="rightArrow">
@@ -1897,7 +1898,7 @@
         </p:nvSpPr>
         <p:spPr>
           <a:xfrm>
-            <a:off x="4041648" y="2313432"/>
+            <a:off x="4041648" y="2212848"/>
             <a:ext cx="475488" cy="475488"/>
           </a:xfrm>
           <a:prstGeom prst="ellipse">
@@ -1930,7 +1931,7 @@
         </p:blipFill>
         <p:spPr>
           <a:xfrm>
-            <a:off x="4142232" y="2414016"/>
+            <a:off x="4142232" y="2313432"/>
             <a:ext cx="274320" cy="274320"/>
           </a:xfrm>
           <a:prstGeom prst="rect">
@@ -1946,8 +1947,8 @@
         </p:nvSpPr>
         <p:spPr>
           <a:xfrm>
-            <a:off x="4663440" y="2148840"/>
-            <a:ext cx="2395728" cy="804672"/>
+            <a:off x="4663440" y="2103120"/>
+            <a:ext cx="2395728" cy="694944"/>
           </a:xfrm>
           <a:prstGeom prst="rect">
             <a:avLst/>
@@ -1961,7 +1962,7 @@
           <a:p>
             <a:pPr indent="0" marL="0">
               <a:spcAft>
-                <a:spcPts val="200"/>
+                <a:spcPts val="100"/>
               </a:spcAft>
               <a:buNone/>
             </a:pPr>
@@ -1978,7 +1979,7 @@
           <a:p>
             <a:pPr indent="0" marL="0">
               <a:spcAft>
-                <a:spcPts val="200"/>
+                <a:spcPts val="100"/>
               </a:spcAft>
               <a:buNone/>
             </a:pPr>
@@ -2002,12 +2003,12 @@
         </p:nvSpPr>
         <p:spPr>
           <a:xfrm>
-            <a:off x="457200" y="3154680"/>
-            <a:ext cx="6720840" cy="987552"/>
+            <a:off x="457200" y="2930652"/>
+            <a:ext cx="6720840" cy="786384"/>
           </a:xfrm>
           <a:prstGeom prst="roundRect">
             <a:avLst>
-              <a:gd name="adj" fmla="val 9259"/>
+              <a:gd name="adj" fmla="val 11628"/>
             </a:avLst>
           </a:prstGeom>
           <a:solidFill>
@@ -2029,7 +2030,7 @@
         </p:nvSpPr>
         <p:spPr>
           <a:xfrm>
-            <a:off x="621792" y="3410712"/>
+            <a:off x="621792" y="3086100"/>
             <a:ext cx="475488" cy="475488"/>
           </a:xfrm>
           <a:prstGeom prst="ellipse">
@@ -2066,7 +2067,7 @@
         </p:blipFill>
         <p:spPr>
           <a:xfrm>
-            <a:off x="722376" y="3511296"/>
+            <a:off x="722376" y="3186684"/>
             <a:ext cx="274320" cy="274320"/>
           </a:xfrm>
           <a:prstGeom prst="rect">
@@ -2082,8 +2083,8 @@
         </p:nvSpPr>
         <p:spPr>
           <a:xfrm>
-            <a:off x="1243584" y="3246120"/>
-            <a:ext cx="2240280" cy="804672"/>
+            <a:off x="1243584" y="2976372"/>
+            <a:ext cx="2240280" cy="694944"/>
           </a:xfrm>
           <a:prstGeom prst="rect">
             <a:avLst/>
@@ -2097,7 +2098,7 @@
           <a:p>
             <a:pPr indent="0" marL="0">
               <a:spcAft>
-                <a:spcPts val="200"/>
+                <a:spcPts val="100"/>
               </a:spcAft>
               <a:buNone/>
             </a:pPr>
@@ -2114,7 +2115,7 @@
           <a:p>
             <a:pPr indent="0" marL="0">
               <a:spcAft>
-                <a:spcPts val="200"/>
+                <a:spcPts val="100"/>
               </a:spcAft>
               <a:buNone/>
             </a:pPr>
@@ -2138,7 +2139,7 @@
         </p:nvSpPr>
         <p:spPr>
           <a:xfrm>
-            <a:off x="3593592" y="3538728"/>
+            <a:off x="3593592" y="3214116"/>
             <a:ext cx="292608" cy="219456"/>
           </a:xfrm>
           <a:prstGeom prst="rightArrow">
@@ -2163,7 +2164,7 @@
         </p:nvSpPr>
         <p:spPr>
           <a:xfrm>
-            <a:off x="4041648" y="3410712"/>
+            <a:off x="4041648" y="3086100"/>
             <a:ext cx="475488" cy="475488"/>
           </a:xfrm>
           <a:prstGeom prst="ellipse">
@@ -2196,7 +2197,7 @@
         </p:blipFill>
         <p:spPr>
           <a:xfrm>
-            <a:off x="4142232" y="3511296"/>
+            <a:off x="4142232" y="3186684"/>
             <a:ext cx="274320" cy="274320"/>
           </a:xfrm>
           <a:prstGeom prst="rect">
@@ -2212,8 +2213,8 @@
         </p:nvSpPr>
         <p:spPr>
           <a:xfrm>
-            <a:off x="4663440" y="3246120"/>
-            <a:ext cx="2395728" cy="804672"/>
+            <a:off x="4663440" y="2976372"/>
+            <a:ext cx="2395728" cy="694944"/>
           </a:xfrm>
           <a:prstGeom prst="rect">
             <a:avLst/>
@@ -2227,7 +2228,7 @@
           <a:p>
             <a:pPr indent="0" marL="0">
               <a:spcAft>
-                <a:spcPts val="200"/>
+                <a:spcPts val="100"/>
               </a:spcAft>
               <a:buNone/>
             </a:pPr>
@@ -2244,7 +2245,7 @@
           <a:p>
             <a:pPr indent="0" marL="0">
               <a:spcAft>
-                <a:spcPts val="200"/>
+                <a:spcPts val="100"/>
               </a:spcAft>
               <a:buNone/>
             </a:pPr>
@@ -2268,12 +2269,12 @@
         </p:nvSpPr>
         <p:spPr>
           <a:xfrm>
-            <a:off x="457200" y="4251960"/>
-            <a:ext cx="6720840" cy="987552"/>
+            <a:off x="457200" y="3803904"/>
+            <a:ext cx="6720840" cy="786384"/>
           </a:xfrm>
           <a:prstGeom prst="roundRect">
             <a:avLst>
-              <a:gd name="adj" fmla="val 9259"/>
+              <a:gd name="adj" fmla="val 11628"/>
             </a:avLst>
           </a:prstGeom>
           <a:solidFill>
@@ -2295,7 +2296,7 @@
         </p:nvSpPr>
         <p:spPr>
           <a:xfrm>
-            <a:off x="621792" y="4507992"/>
+            <a:off x="621792" y="3959352"/>
             <a:ext cx="475488" cy="475488"/>
           </a:xfrm>
           <a:prstGeom prst="ellipse">
@@ -2332,7 +2333,7 @@
         </p:blipFill>
         <p:spPr>
           <a:xfrm>
-            <a:off x="722376" y="4608576"/>
+            <a:off x="722376" y="4059936"/>
             <a:ext cx="274320" cy="274320"/>
           </a:xfrm>
           <a:prstGeom prst="rect">
@@ -2348,8 +2349,8 @@
         </p:nvSpPr>
         <p:spPr>
           <a:xfrm>
-            <a:off x="1243584" y="4343400"/>
-            <a:ext cx="2240280" cy="804672"/>
+            <a:off x="1243584" y="3849624"/>
+            <a:ext cx="2240280" cy="694944"/>
           </a:xfrm>
           <a:prstGeom prst="rect">
             <a:avLst/>
@@ -2363,7 +2364,7 @@
           <a:p>
             <a:pPr indent="0" marL="0">
               <a:spcAft>
-                <a:spcPts val="200"/>
+                <a:spcPts val="100"/>
               </a:spcAft>
               <a:buNone/>
             </a:pPr>
@@ -2380,7 +2381,7 @@
           <a:p>
             <a:pPr indent="0" marL="0">
               <a:spcAft>
-                <a:spcPts val="200"/>
+                <a:spcPts val="100"/>
               </a:spcAft>
               <a:buNone/>
             </a:pPr>
@@ -2404,7 +2405,7 @@
         </p:nvSpPr>
         <p:spPr>
           <a:xfrm>
-            <a:off x="3593592" y="4636008"/>
+            <a:off x="3593592" y="4087368"/>
             <a:ext cx="292608" cy="219456"/>
           </a:xfrm>
           <a:prstGeom prst="rightArrow">
@@ -2429,7 +2430,7 @@
         </p:nvSpPr>
         <p:spPr>
           <a:xfrm>
-            <a:off x="4041648" y="4507992"/>
+            <a:off x="4041648" y="3959352"/>
             <a:ext cx="475488" cy="475488"/>
           </a:xfrm>
           <a:prstGeom prst="ellipse">
@@ -2462,7 +2463,7 @@
         </p:blipFill>
         <p:spPr>
           <a:xfrm>
-            <a:off x="4142232" y="4608576"/>
+            <a:off x="4142232" y="4059936"/>
             <a:ext cx="274320" cy="274320"/>
           </a:xfrm>
           <a:prstGeom prst="rect">
@@ -2478,8 +2479,8 @@
         </p:nvSpPr>
         <p:spPr>
           <a:xfrm>
-            <a:off x="4663440" y="4343400"/>
-            <a:ext cx="2395728" cy="804672"/>
+            <a:off x="4663440" y="3849624"/>
+            <a:ext cx="2395728" cy="694944"/>
           </a:xfrm>
           <a:prstGeom prst="rect">
             <a:avLst/>
@@ -2493,7 +2494,7 @@
           <a:p>
             <a:pPr indent="0" marL="0">
               <a:spcAft>
-                <a:spcPts val="200"/>
+                <a:spcPts val="100"/>
               </a:spcAft>
               <a:buNone/>
             </a:pPr>
@@ -2510,7 +2511,7 @@
           <a:p>
             <a:pPr indent="0" marL="0">
               <a:spcAft>
-                <a:spcPts val="200"/>
+                <a:spcPts val="100"/>
               </a:spcAft>
               <a:buNone/>
             </a:pPr>
@@ -2534,12 +2535,12 @@
         </p:nvSpPr>
         <p:spPr>
           <a:xfrm>
-            <a:off x="457200" y="5349240"/>
-            <a:ext cx="6720840" cy="987552"/>
+            <a:off x="457200" y="4677156"/>
+            <a:ext cx="6720840" cy="786384"/>
           </a:xfrm>
           <a:prstGeom prst="roundRect">
             <a:avLst>
-              <a:gd name="adj" fmla="val 9259"/>
+              <a:gd name="adj" fmla="val 11628"/>
             </a:avLst>
           </a:prstGeom>
           <a:solidFill>
@@ -2561,7 +2562,7 @@
         </p:nvSpPr>
         <p:spPr>
           <a:xfrm>
-            <a:off x="621792" y="5605272"/>
+            <a:off x="621792" y="4832604"/>
             <a:ext cx="475488" cy="475488"/>
           </a:xfrm>
           <a:prstGeom prst="ellipse">
@@ -2598,7 +2599,7 @@
         </p:blipFill>
         <p:spPr>
           <a:xfrm>
-            <a:off x="722376" y="5705856"/>
+            <a:off x="722376" y="4933188"/>
             <a:ext cx="274320" cy="274320"/>
           </a:xfrm>
           <a:prstGeom prst="rect">
@@ -2614,8 +2615,8 @@
         </p:nvSpPr>
         <p:spPr>
           <a:xfrm>
-            <a:off x="1243584" y="5440680"/>
-            <a:ext cx="2240280" cy="804672"/>
+            <a:off x="1243584" y="4722876"/>
+            <a:ext cx="2240280" cy="694944"/>
           </a:xfrm>
           <a:prstGeom prst="rect">
             <a:avLst/>
@@ -2629,7 +2630,7 @@
           <a:p>
             <a:pPr indent="0" marL="0">
               <a:spcAft>
-                <a:spcPts val="200"/>
+                <a:spcPts val="100"/>
               </a:spcAft>
               <a:buNone/>
             </a:pPr>
@@ -2646,7 +2647,7 @@
           <a:p>
             <a:pPr indent="0" marL="0">
               <a:spcAft>
-                <a:spcPts val="200"/>
+                <a:spcPts val="100"/>
               </a:spcAft>
               <a:buNone/>
             </a:pPr>
@@ -2670,7 +2671,7 @@
         </p:nvSpPr>
         <p:spPr>
           <a:xfrm>
-            <a:off x="3593592" y="5733288"/>
+            <a:off x="3593592" y="4960620"/>
             <a:ext cx="292608" cy="219456"/>
           </a:xfrm>
           <a:prstGeom prst="rightArrow">
@@ -2695,7 +2696,7 @@
         </p:nvSpPr>
         <p:spPr>
           <a:xfrm>
-            <a:off x="4041648" y="5605272"/>
+            <a:off x="4041648" y="4832604"/>
             <a:ext cx="475488" cy="475488"/>
           </a:xfrm>
           <a:prstGeom prst="ellipse">
@@ -2728,7 +2729,7 @@
         </p:blipFill>
         <p:spPr>
           <a:xfrm>
-            <a:off x="4142232" y="5705856"/>
+            <a:off x="4142232" y="4933188"/>
             <a:ext cx="274320" cy="274320"/>
           </a:xfrm>
           <a:prstGeom prst="rect">
@@ -2744,8 +2745,8 @@
         </p:nvSpPr>
         <p:spPr>
           <a:xfrm>
-            <a:off x="4663440" y="5440680"/>
-            <a:ext cx="2395728" cy="804672"/>
+            <a:off x="4663440" y="4722876"/>
+            <a:ext cx="2395728" cy="694944"/>
           </a:xfrm>
           <a:prstGeom prst="rect">
             <a:avLst/>
@@ -2759,7 +2760,7 @@
           <a:p>
             <a:pPr indent="0" marL="0">
               <a:spcAft>
-                <a:spcPts val="200"/>
+                <a:spcPts val="100"/>
               </a:spcAft>
               <a:buNone/>
             </a:pPr>
@@ -2776,7 +2777,7 @@
           <a:p>
             <a:pPr indent="0" marL="0">
               <a:spcAft>
-                <a:spcPts val="200"/>
+                <a:spcPts val="100"/>
               </a:spcAft>
               <a:buNone/>
             </a:pPr>
@@ -2786,7 +2787,7 @@
                   <a:schemeClr val="tx2"/>
                 </a:solidFill>
               </a:rPr>
-              <a:t>Utilisation by zone and team, capacity outlook</a:t>
+              <a:t>Utilisation by zone and team, busiest days</a:t>
             </a:r>
             <a:endParaRPr lang="en-US" sz="1500" dirty="0"/>
           </a:p>
@@ -2794,7 +2795,273 @@
       </p:sp>
       <p:sp>
         <p:nvSpPr>
-          <p:cNvPr id="39" name="Screenshot frame"/>
+          <p:cNvPr id="39" name="Row 5"/>
+          <p:cNvSpPr/>
+          <p:nvPr/>
+        </p:nvSpPr>
+        <p:spPr>
+          <a:xfrm>
+            <a:off x="457200" y="5550408"/>
+            <a:ext cx="6720840" cy="786384"/>
+          </a:xfrm>
+          <a:prstGeom prst="roundRect">
+            <a:avLst>
+              <a:gd name="adj" fmla="val 11628"/>
+            </a:avLst>
+          </a:prstGeom>
+          <a:solidFill>
+            <a:schemeClr val="bg2"/>
+          </a:solidFill>
+          <a:ln w="12700">
+            <a:solidFill>
+              <a:schemeClr val="bg2"/>
+            </a:solidFill>
+            <a:prstDash val="solid"/>
+          </a:ln>
+        </p:spPr>
+      </p:sp>
+      <p:sp>
+        <p:nvSpPr>
+          <p:cNvPr id="40" name="Pain icon circle 5"/>
+          <p:cNvSpPr/>
+          <p:nvPr/>
+        </p:nvSpPr>
+        <p:spPr>
+          <a:xfrm>
+            <a:off x="621792" y="5705856"/>
+            <a:ext cx="475488" cy="475488"/>
+          </a:xfrm>
+          <a:prstGeom prst="ellipse">
+            <a:avLst/>
+          </a:prstGeom>
+          <a:solidFill>
+            <a:schemeClr val="accent6">
+              <a:alpha val="15000"/>
+            </a:schemeClr>
+          </a:solidFill>
+          <a:ln w="12700">
+            <a:solidFill>
+              <a:schemeClr val="accent6">
+                <a:alpha val="15000"/>
+              </a:schemeClr>
+            </a:solidFill>
+            <a:prstDash val="solid"/>
+          </a:ln>
+        </p:spPr>
+      </p:sp>
+      <p:pic>
+        <p:nvPicPr>
+          <p:cNvPr id="41" name="Pain icon 5" descr="New team asks for seats icon">    </p:cNvPr>
+          <p:cNvPicPr>
+            <a:picLocks noChangeAspect="1"/>
+          </p:cNvPicPr>
+          <p:nvPr/>
+        </p:nvPicPr>
+        <p:blipFill>
+          <a:blip r:embed="rId10"/>
+          <a:stretch>
+            <a:fillRect/>
+          </a:stretch>
+        </p:blipFill>
+        <p:spPr>
+          <a:xfrm>
+            <a:off x="722376" y="5806440"/>
+            <a:ext cx="274320" cy="274320"/>
+          </a:xfrm>
+          <a:prstGeom prst="rect">
+            <a:avLst/>
+          </a:prstGeom>
+        </p:spPr>
+      </p:pic>
+      <p:sp>
+        <p:nvSpPr>
+          <p:cNvPr id="42" name="Pain 5"/>
+          <p:cNvSpPr txBox="1"/>
+          <p:nvPr/>
+        </p:nvSpPr>
+        <p:spPr>
+          <a:xfrm>
+            <a:off x="1243584" y="5596128"/>
+            <a:ext cx="2240280" cy="694944"/>
+          </a:xfrm>
+          <a:prstGeom prst="rect">
+            <a:avLst/>
+          </a:prstGeom>
+          <a:noFill/>
+          <a:ln/>
+        </p:spPr>
+        <p:txBody>
+          <a:bodyPr wrap="square" lIns="0" tIns="0" rIns="0" bIns="0" rtlCol="0" anchor="ctr"/>
+          <a:lstStyle/>
+          <a:p>
+            <a:pPr indent="0" marL="0">
+              <a:spcAft>
+                <a:spcPts val="100"/>
+              </a:spcAft>
+              <a:buNone/>
+            </a:pPr>
+            <a:r>
+              <a:rPr lang="en-US" sz="1500" b="1" dirty="0">
+                <a:solidFill>
+                  <a:schemeClr val="tx1"/>
+                </a:solidFill>
+              </a:rPr>
+              <a:t>New team asks for seats</a:t>
+            </a:r>
+            <a:endParaRPr lang="en-US" sz="1500" dirty="0"/>
+          </a:p>
+          <a:p>
+            <a:pPr indent="0" marL="0">
+              <a:spcAft>
+                <a:spcPts val="100"/>
+              </a:spcAft>
+              <a:buNone/>
+            </a:pPr>
+            <a:r>
+              <a:rPr lang="en-US" sz="1400" dirty="0">
+                <a:solidFill>
+                  <a:schemeClr val="tx2"/>
+                </a:solidFill>
+              </a:rPr>
+              <a:t>Admin can’t tell if the floor can take them</a:t>
+            </a:r>
+            <a:endParaRPr lang="en-US" sz="1500" dirty="0"/>
+          </a:p>
+        </p:txBody>
+      </p:sp>
+      <p:sp>
+        <p:nvSpPr>
+          <p:cNvPr id="43" name="Arrow 5"/>
+          <p:cNvSpPr/>
+          <p:nvPr/>
+        </p:nvSpPr>
+        <p:spPr>
+          <a:xfrm>
+            <a:off x="3593592" y="5833872"/>
+            <a:ext cx="292608" cy="219456"/>
+          </a:xfrm>
+          <a:prstGeom prst="rightArrow">
+            <a:avLst/>
+          </a:prstGeom>
+          <a:solidFill>
+            <a:schemeClr val="accent1"/>
+          </a:solidFill>
+          <a:ln w="12700">
+            <a:solidFill>
+              <a:schemeClr val="accent1"/>
+            </a:solidFill>
+            <a:prstDash val="solid"/>
+          </a:ln>
+        </p:spPr>
+      </p:sp>
+      <p:sp>
+        <p:nvSpPr>
+          <p:cNvPr id="44" name="Fix icon circle 5"/>
+          <p:cNvSpPr/>
+          <p:nvPr/>
+        </p:nvSpPr>
+        <p:spPr>
+          <a:xfrm>
+            <a:off x="4041648" y="5705856"/>
+            <a:ext cx="475488" cy="475488"/>
+          </a:xfrm>
+          <a:prstGeom prst="ellipse">
+            <a:avLst/>
+          </a:prstGeom>
+          <a:solidFill>
+            <a:schemeClr val="accent1"/>
+          </a:solidFill>
+          <a:ln w="12700">
+            <a:solidFill>
+              <a:schemeClr val="accent1"/>
+            </a:solidFill>
+            <a:prstDash val="solid"/>
+          </a:ln>
+        </p:spPr>
+      </p:sp>
+      <p:pic>
+        <p:nvPicPr>
+          <p:cNvPr id="45" name="Fix icon 5" descr="What-if planner icon">    </p:cNvPr>
+          <p:cNvPicPr>
+            <a:picLocks noChangeAspect="1"/>
+          </p:cNvPicPr>
+          <p:nvPr/>
+        </p:nvPicPr>
+        <p:blipFill>
+          <a:blip r:embed="rId11"/>
+          <a:stretch>
+            <a:fillRect/>
+          </a:stretch>
+        </p:blipFill>
+        <p:spPr>
+          <a:xfrm>
+            <a:off x="4142232" y="5806440"/>
+            <a:ext cx="274320" cy="274320"/>
+          </a:xfrm>
+          <a:prstGeom prst="rect">
+            <a:avLst/>
+          </a:prstGeom>
+        </p:spPr>
+      </p:pic>
+      <p:sp>
+        <p:nvSpPr>
+          <p:cNvPr id="46" name="Fix 5"/>
+          <p:cNvSpPr txBox="1"/>
+          <p:nvPr/>
+        </p:nvSpPr>
+        <p:spPr>
+          <a:xfrm>
+            <a:off x="4663440" y="5596128"/>
+            <a:ext cx="2395728" cy="694944"/>
+          </a:xfrm>
+          <a:prstGeom prst="rect">
+            <a:avLst/>
+          </a:prstGeom>
+          <a:noFill/>
+          <a:ln/>
+        </p:spPr>
+        <p:txBody>
+          <a:bodyPr wrap="square" lIns="0" tIns="0" rIns="0" bIns="0" rtlCol="0" anchor="ctr"/>
+          <a:lstStyle/>
+          <a:p>
+            <a:pPr indent="0" marL="0">
+              <a:spcAft>
+                <a:spcPts val="100"/>
+              </a:spcAft>
+              <a:buNone/>
+            </a:pPr>
+            <a:r>
+              <a:rPr lang="en-US" sz="1500" b="1" dirty="0">
+                <a:solidFill>
+                  <a:schemeClr val="tx1"/>
+                </a:solidFill>
+              </a:rPr>
+              <a:t>What-if planner</a:t>
+            </a:r>
+            <a:endParaRPr lang="en-US" sz="1500" dirty="0"/>
+          </a:p>
+          <a:p>
+            <a:pPr indent="0" marL="0">
+              <a:spcAft>
+                <a:spcPts val="100"/>
+              </a:spcAft>
+              <a:buNone/>
+            </a:pPr>
+            <a:r>
+              <a:rPr lang="en-US" sz="1400" dirty="0">
+                <a:solidFill>
+                  <a:schemeClr val="tx2"/>
+                </a:solidFill>
+              </a:rPr>
+              <a:t>Add their headcount, see if seats run out</a:t>
+            </a:r>
+            <a:endParaRPr lang="en-US" sz="1500" dirty="0"/>
+          </a:p>
+        </p:txBody>
+      </p:sp>
+      <p:sp>
+        <p:nvSpPr>
+          <p:cNvPr id="47" name="Screenshot frame"/>
           <p:cNvSpPr/>
           <p:nvPr/>
         </p:nvSpPr>
@@ -2828,14 +3095,14 @@
       </p:sp>
       <p:pic>
         <p:nvPicPr>
-          <p:cNvPr id="40" name="Dashboard screenshot" descr="Admin dashboard: live floor plan coloured by project team, KPI cards and the colleague finder">    </p:cNvPr>
+          <p:cNvPr id="48" name="Dashboard screenshot" descr="Admin dashboard: live floor plan coloured by project team, KPI cards and the colleague finder">    </p:cNvPr>
           <p:cNvPicPr>
             <a:picLocks noChangeAspect="1"/>
           </p:cNvPicPr>
           <p:nvPr/>
         </p:nvPicPr>
         <p:blipFill>
-          <a:blip r:embed="rId10"/>
+          <a:blip r:embed="rId12"/>
           <a:stretch>
             <a:fillRect/>
           </a:stretch>
@@ -2852,7 +3119,7 @@
       </p:pic>
       <p:sp>
         <p:nvSpPr>
-          <p:cNvPr id="41" name="Screenshot caption"/>
+          <p:cNvPr id="49" name="Screenshot caption"/>
           <p:cNvSpPr txBox="1"/>
           <p:nvPr/>
         </p:nvSpPr>
@@ -2888,7 +3155,7 @@
       </p:sp>
       <p:sp>
         <p:nvSpPr>
-          <p:cNvPr id="42" name="Figure card 1"/>
+          <p:cNvPr id="50" name="Figure card 1"/>
           <p:cNvSpPr/>
           <p:nvPr/>
         </p:nvSpPr>
@@ -2915,7 +3182,7 @@
       </p:sp>
       <p:sp>
         <p:nvSpPr>
-          <p:cNvPr id="43" name="Figure 1"/>
+          <p:cNvPr id="51" name="Figure 1"/>
           <p:cNvSpPr txBox="1"/>
           <p:nvPr/>
         </p:nvSpPr>
@@ -2965,7 +3232,7 @@
       </p:sp>
       <p:sp>
         <p:nvSpPr>
-          <p:cNvPr id="44" name="Figure card 2"/>
+          <p:cNvPr id="52" name="Figure card 2"/>
           <p:cNvSpPr/>
           <p:nvPr/>
         </p:nvSpPr>
@@ -2992,7 +3259,7 @@
       </p:sp>
       <p:sp>
         <p:nvSpPr>
-          <p:cNvPr id="45" name="Figure 2"/>
+          <p:cNvPr id="53" name="Figure 2"/>
           <p:cNvSpPr txBox="1"/>
           <p:nvPr/>
         </p:nvSpPr>
@@ -3042,7 +3309,7 @@
       </p:sp>
       <p:sp>
         <p:nvSpPr>
-          <p:cNvPr id="46" name="Figure card 3"/>
+          <p:cNvPr id="54" name="Figure card 3"/>
           <p:cNvSpPr/>
           <p:nvPr/>
         </p:nvSpPr>
@@ -3069,7 +3336,7 @@
       </p:sp>
       <p:sp>
         <p:nvSpPr>
-          <p:cNvPr id="47" name="Figure 3"/>
+          <p:cNvPr id="55" name="Figure 3"/>
           <p:cNvSpPr txBox="1"/>
           <p:nvPr/>
         </p:nvSpPr>
@@ -3119,7 +3386,7 @@
       </p:sp>
       <p:sp>
         <p:nvSpPr>
-          <p:cNvPr id="48" name="Figure card 4"/>
+          <p:cNvPr id="56" name="Figure card 4"/>
           <p:cNvSpPr/>
           <p:nvPr/>
         </p:nvSpPr>
@@ -3146,7 +3413,7 @@
       </p:sp>
       <p:sp>
         <p:nvSpPr>
-          <p:cNvPr id="49" name="Figure 4"/>
+          <p:cNvPr id="57" name="Figure 4"/>
           <p:cNvSpPr txBox="1"/>
           <p:nvPr/>
         </p:nvSpPr>

</xml_diff>

<commit_message>
Add seat-requests cartoon slide to project deck
New slide 2 shows the administrator's side: seat requests from new
teams, no reliable view of how full the floor is, and no answer to
whether another team fits.

Co-Authored-By: Claude Opus 5.5 <noreply@anthropic.com>
Claude-Session: https://claude.ai/code/session_01R5PsyFbuq2Dda7FuaF5nhy
</commit_message>
<xml_diff>
--- a/docs/Hot-Desk-Monitor.pptx
+++ b/docs/Hot-Desk-Monitor.pptx
@@ -7,9 +7,10 @@
   <p:sldIdLst>
     <p:sldId id="256" r:id="rId2"/>
     <p:sldId id="257" r:id="rId3"/>
+    <p:sldId id="258" r:id="rId4"/>
   </p:sldIdLst>
   <p:notesMasterIdLst>
-    <p:notesMasterId r:id="rId4"/>
+    <p:notesMasterId r:id="rId5"/>
   </p:notesMasterIdLst>
   <p:sldSz cx="12192000" cy="6858000"/>
   <p:notesSz cx="6858000" cy="12192000"/>
@@ -108,14 +109,19 @@
   <p:extLst>
     <p:ext uri="{521415D9-36F7-43E2-AB2F-B90AF26B5E84}">
       <p14:sectionLst xmlns:p14="http://schemas.microsoft.com/office/powerpoint/2010/main">
-        <p14:section name="Introduction" id="{ac0e7d49-511a-662b-d0e2-14fcdb6064ac}">
+        <p14:section name="Introduction" id="{de448b3a-ddfe-adda-e6b3-0859ca709e6d}">
           <p14:sldIdLst>
             <p14:sldId id="256"/>
           </p14:sldIdLst>
         </p14:section>
-        <p14:section name="Overview" id="{2b53a16f-ac02-20f3-ff92-f61b1ab51aca}">
+        <p14:section name="Seat requests" id="{9e1c33a8-5d1a-b692-0998-b3491310f116}">
           <p14:sldIdLst>
             <p14:sldId id="257"/>
+          </p14:sldIdLst>
+        </p14:section>
+        <p14:section name="Overview" id="{793e23b9-2133-a41f-247e-c8eb007551e9}">
+          <p14:sldIdLst>
+            <p14:sldId id="258"/>
           </p14:sldIdLst>
         </p14:section>
       </p14:sectionLst>
@@ -527,7 +533,7 @@
 Crowded: one zone, here the Digital Factory, is packed because teams squeeze in where they always sit; latecomers from the same project have nowhere to go.
 Empty: at the same time another zone, here the AI Lab, is almost empty, a short walk away, but nobody knows.
 Scattered: teammates end up on different floors and spend time on the phone working out where everyone is.
-The cost: time lost every morning, teams kept apart, and space that is crowded in one place and empty in another. Next slide: how Hot Desk Monitor fixes each of these.</a:t>
+The cost: time lost every morning, teams kept apart, and space that is crowded in one place and empty in another. Next: the same problem from the office administrator’s side.</a:t>
             </a:r>
             <a:endParaRPr lang="en-US" dirty="0"/>
           </a:p>
@@ -615,6 +621,99 @@
           <a:p>
             <a:r>
               <a:rPr lang="en-US" dirty="0"/>
+              <a:t>The same problem, seen from the office administrator’s desk.
+Monday 9:00: requests come in from teams starting new projects or taking on joiners, e.g. SAP wants 12 seats, DDAP 6 more, ITGC has 8 joiners next week.
+Head count: the only way to check is to walk the floor, and a count can’t tell a bag from a person, or a busy Tuesday from a quiet Friday.
+The spreadsheet: the seat plan was last updated months ago, so it doesn’t say how many desks are really used.
+So the answer is “let me get back to you”: either a team is turned away from space that is actually free, or squeezed onto a floor that is already full.
+Next slide: how Hot Desk Monitor fixes these, including usage insights and the what-if planner for new teams.</a:t>
+            </a:r>
+            <a:endParaRPr lang="en-US" dirty="0"/>
+          </a:p>
+        </p:txBody>
+      </p:sp>
+      <p:sp>
+        <p:nvSpPr>
+          <p:cNvPr id="4" name="Slide Number Placeholder 3"/>
+          <p:cNvSpPr>
+            <a:spLocks noGrp="1"/>
+          </p:cNvSpPr>
+          <p:nvPr>
+            <p:ph type="sldNum" sz="quarter" idx="10"/>
+          </p:nvPr>
+        </p:nvSpPr>
+        <p:spPr/>
+        <p:txBody>
+          <a:bodyPr/>
+          <a:lstStyle/>
+          <a:p>
+            <a:fld id="{F7021451-1387-4CA6-816F-3879F97B5CBC}" type="slidenum">
+              <a:rPr lang="en-US"/>
+              <a:t>2</a:t>
+            </a:fld>
+            <a:endParaRPr lang="en-US"/>
+          </a:p>
+        </p:txBody>
+      </p:sp>
+    </p:spTree>
+    <p:extLst>
+      <p:ext uri="{BB962C8B-B14F-4D97-AF65-F5344CB8AC3E}">
+        <p14:creationId xmlns:p14="http://schemas.microsoft.com/office/powerpoint/2010/main" val="1024086991"/>
+      </p:ext>
+    </p:extLst>
+  </p:cSld>
+  <p:clrMapOvr>
+    <a:masterClrMapping/>
+  </p:clrMapOvr>
+</p:notes>
+</file>
+
+<file path=ppt/notesSlides/notesSlide3.xml><?xml version="1.0" encoding="utf-8"?>
+<p:notes xmlns:a="http://schemas.openxmlformats.org/drawingml/2006/main" xmlns:r="http://schemas.openxmlformats.org/officeDocument/2006/relationships" xmlns:p="http://schemas.openxmlformats.org/presentationml/2006/main">
+  <p:cSld>
+    <p:spTree>
+      <p:nvGrpSpPr>
+        <p:cNvPr id="1" name=""/>
+        <p:cNvGrpSpPr/>
+        <p:nvPr/>
+      </p:nvGrpSpPr>
+      <p:grpSpPr>
+        <a:xfrm>
+          <a:off x="0" y="0"/>
+          <a:ext cx="0" cy="0"/>
+          <a:chOff x="0" y="0"/>
+          <a:chExt cx="0" cy="0"/>
+        </a:xfrm>
+      </p:grpSpPr>
+      <p:sp>
+        <p:nvSpPr>
+          <p:cNvPr id="2" name="Slide Image Placeholder 1"/>
+          <p:cNvSpPr>
+            <a:spLocks noGrp="1" noRot="1" noChangeAspect="1"/>
+          </p:cNvSpPr>
+          <p:nvPr>
+            <p:ph type="sldImg"/>
+          </p:nvPr>
+        </p:nvSpPr>
+        <p:spPr/>
+      </p:sp>
+      <p:sp>
+        <p:nvSpPr>
+          <p:cNvPr id="3" name="Notes Placeholder 2"/>
+          <p:cNvSpPr>
+            <a:spLocks noGrp="1"/>
+          </p:cNvSpPr>
+          <p:nvPr>
+            <p:ph type="body" idx="1"/>
+          </p:nvPr>
+        </p:nvSpPr>
+        <p:spPr/>
+        <p:txBody>
+          <a:bodyPr/>
+          <a:lstStyle/>
+          <a:p>
+            <a:r>
+              <a:rPr lang="en-US" dirty="0"/>
               <a:t>Hot desking only works if people can find a free desk quickly and desks are not blocked by people who are not using them. Hot Desk Monitor tackles five pains.
 1. Hunting for a free desk: instead of walking the floors, people see free desks on the live floor plan, on the office wall display, or on their phone.
 2. Ghost desks: desks held by a bag, or booked and never used. Under-desk sensors see when someone leaves; the desk frees itself 20 minutes later. Reservations nobody checks in to are released 30 minutes after the slot starts, and check-ins expire unless renewed.
@@ -644,7 +743,7 @@
           <a:p>
             <a:fld id="{F7021451-1387-4CA6-816F-3879F97B5CBC}" type="slidenum">
               <a:rPr lang="en-US"/>
-              <a:t>2</a:t>
+              <a:t>3</a:t>
             </a:fld>
             <a:endParaRPr lang="en-US"/>
           </a:p>
@@ -1543,6 +1642,449 @@
 <file path=ppt/slides/slide2.xml><?xml version="1.0" encoding="utf-8"?>
 <p:sld xmlns:a="http://schemas.openxmlformats.org/drawingml/2006/main" xmlns:r="http://schemas.openxmlformats.org/officeDocument/2006/relationships" xmlns:p="http://schemas.openxmlformats.org/presentationml/2006/main">
   <p:cSld name="Slide 2">
+    <p:spTree>
+      <p:nvGrpSpPr>
+        <p:cNvPr id="1" name=""/>
+        <p:cNvGrpSpPr/>
+        <p:nvPr/>
+      </p:nvGrpSpPr>
+      <p:grpSpPr>
+        <a:xfrm>
+          <a:off x="0" y="0"/>
+          <a:ext cx="0" cy="0"/>
+          <a:chOff x="0" y="0"/>
+          <a:chExt cx="0" cy="0"/>
+        </a:xfrm>
+      </p:grpSpPr>
+      <p:pic>
+        <p:nvPicPr>
+          <p:cNvPr id="2" name="Logo" descr="Hot Desk logo">    </p:cNvPr>
+          <p:cNvPicPr>
+            <a:picLocks noChangeAspect="1"/>
+          </p:cNvPicPr>
+          <p:nvPr/>
+        </p:nvPicPr>
+        <p:blipFill>
+          <a:blip r:embed="rId1"/>
+          <a:stretch>
+            <a:fillRect/>
+          </a:stretch>
+        </p:blipFill>
+        <p:spPr>
+          <a:xfrm>
+            <a:off x="457200" y="411480"/>
+            <a:ext cx="566928" cy="566928"/>
+          </a:xfrm>
+          <a:prstGeom prst="rect">
+            <a:avLst/>
+          </a:prstGeom>
+        </p:spPr>
+      </p:pic>
+      <p:sp>
+        <p:nvSpPr>
+          <p:cNvPr id="3" name="Text 0"/>
+          <p:cNvSpPr/>
+          <p:nvPr>
+            <p:ph idx="100" type="title" hasCustomPrompt="1"/>
+          </p:nvPr>
+        </p:nvSpPr>
+        <p:spPr>
+          <a:xfrm>
+            <a:off x="1234440" y="384048"/>
+            <a:ext cx="10469880" cy="566928"/>
+          </a:xfrm>
+          <a:prstGeom prst="rect">
+            <a:avLst/>
+          </a:prstGeom>
+          <a:noFill/>
+          <a:ln/>
+        </p:spPr>
+        <p:txBody>
+          <a:bodyPr wrap="square" lIns="0" tIns="0" rIns="0" bIns="0" rtlCol="0" anchor="ctr"/>
+          <a:lstStyle/>
+          <a:p>
+            <a:pPr indent="0" marL="0">
+              <a:buNone/>
+            </a:pPr>
+            <a:r>
+              <a:rPr lang="en-US" sz="3000" b="1" dirty="0">
+                <a:solidFill>
+                  <a:schemeClr val="tx1"/>
+                </a:solidFill>
+              </a:rPr>
+              <a:t>Seat requests: can we fit another team?</a:t>
+            </a:r>
+            <a:endParaRPr lang="en-US" sz="3000" dirty="0"/>
+          </a:p>
+        </p:txBody>
+      </p:sp>
+      <p:sp>
+        <p:nvSpPr>
+          <p:cNvPr id="4" name="Text 0"/>
+          <p:cNvSpPr/>
+          <p:nvPr>
+            <p:ph idx="101" type="body" hasCustomPrompt="1"/>
+          </p:nvPr>
+        </p:nvSpPr>
+        <p:spPr>
+          <a:xfrm>
+            <a:off x="1234440" y="987552"/>
+            <a:ext cx="10469880" cy="566928"/>
+          </a:xfrm>
+          <a:prstGeom prst="rect">
+            <a:avLst/>
+          </a:prstGeom>
+          <a:noFill/>
+          <a:ln/>
+        </p:spPr>
+        <p:txBody>
+          <a:bodyPr wrap="square" lIns="0" tIns="0" rIns="0" bIns="0" rtlCol="0" anchor="t"/>
+          <a:lstStyle/>
+          <a:p>
+            <a:pPr indent="0" marL="0">
+              <a:buNone/>
+            </a:pPr>
+            <a:r>
+              <a:rPr lang="en-US" sz="1600" dirty="0">
+                <a:solidFill>
+                  <a:schemeClr val="tx2"/>
+                </a:solidFill>
+              </a:rPr>
+              <a:t>What the office administrator faces when a new project team asks for desks.</a:t>
+            </a:r>
+            <a:endParaRPr lang="en-US" sz="1600" dirty="0"/>
+          </a:p>
+        </p:txBody>
+      </p:sp>
+      <p:pic>
+        <p:nvPicPr>
+          <p:cNvPr id="5" name="Cartoon panel 1" descr="Panel 1, Monday 9:00: the administrator at their desk faces an inbox of three seat requests (SAP: 12 seats for a new project; DDAP: 6 more desks; ITGC: 8 joiners next week), thinking &quot;Where do I put them all?&quot;">    </p:cNvPr>
+          <p:cNvPicPr>
+            <a:picLocks noChangeAspect="1"/>
+          </p:cNvPicPr>
+          <p:nvPr/>
+        </p:nvPicPr>
+        <p:blipFill>
+          <a:blip r:embed="rId2"/>
+          <a:stretch>
+            <a:fillRect/>
+          </a:stretch>
+        </p:blipFill>
+        <p:spPr>
+          <a:xfrm>
+            <a:off x="457200" y="1691640"/>
+            <a:ext cx="2670048" cy="3115056"/>
+          </a:xfrm>
+          <a:prstGeom prst="rect">
+            <a:avLst/>
+          </a:prstGeom>
+        </p:spPr>
+      </p:pic>
+      <p:sp>
+        <p:nvSpPr>
+          <p:cNvPr id="6" name="Panel caption 1"/>
+          <p:cNvSpPr txBox="1"/>
+          <p:nvPr/>
+        </p:nvSpPr>
+        <p:spPr>
+          <a:xfrm>
+            <a:off x="457200" y="4934712"/>
+            <a:ext cx="2670048" cy="685800"/>
+          </a:xfrm>
+          <a:prstGeom prst="rect">
+            <a:avLst/>
+          </a:prstGeom>
+          <a:noFill/>
+          <a:ln/>
+        </p:spPr>
+        <p:txBody>
+          <a:bodyPr wrap="square" lIns="0" tIns="0" rIns="0" bIns="0" rtlCol="0" anchor="t"/>
+          <a:lstStyle/>
+          <a:p>
+            <a:pPr indent="0" marL="0">
+              <a:buNone/>
+            </a:pPr>
+            <a:r>
+              <a:rPr lang="en-US" sz="1400" dirty="0">
+                <a:solidFill>
+                  <a:schemeClr val="tx1"/>
+                </a:solidFill>
+              </a:rPr>
+              <a:t>Seat requests pile up from teams with new projects and joiners.</a:t>
+            </a:r>
+            <a:endParaRPr lang="en-US" sz="1400" dirty="0"/>
+          </a:p>
+        </p:txBody>
+      </p:sp>
+      <p:pic>
+        <p:nvPicPr>
+          <p:cNvPr id="7" name="Cartoon panel 2" descr="Panel 2, Head count: the administrator walks the floor with a tally clipboard past occupied, bag-claimed and empty desks, thinking &quot;Full? Half empty?&quot;">    </p:cNvPr>
+          <p:cNvPicPr>
+            <a:picLocks noChangeAspect="1"/>
+          </p:cNvPicPr>
+          <p:nvPr/>
+        </p:nvPicPr>
+        <p:blipFill>
+          <a:blip r:embed="rId3"/>
+          <a:stretch>
+            <a:fillRect/>
+          </a:stretch>
+        </p:blipFill>
+        <p:spPr>
+          <a:xfrm>
+            <a:off x="3325368" y="1691640"/>
+            <a:ext cx="2670048" cy="3115056"/>
+          </a:xfrm>
+          <a:prstGeom prst="rect">
+            <a:avLst/>
+          </a:prstGeom>
+        </p:spPr>
+      </p:pic>
+      <p:sp>
+        <p:nvSpPr>
+          <p:cNvPr id="8" name="Panel caption 2"/>
+          <p:cNvSpPr txBox="1"/>
+          <p:nvPr/>
+        </p:nvSpPr>
+        <p:spPr>
+          <a:xfrm>
+            <a:off x="3325368" y="4934712"/>
+            <a:ext cx="2670048" cy="685800"/>
+          </a:xfrm>
+          <a:prstGeom prst="rect">
+            <a:avLst/>
+          </a:prstGeom>
+          <a:noFill/>
+          <a:ln/>
+        </p:spPr>
+        <p:txBody>
+          <a:bodyPr wrap="square" lIns="0" tIns="0" rIns="0" bIns="0" rtlCol="0" anchor="t"/>
+          <a:lstStyle/>
+          <a:p>
+            <a:pPr indent="0" marL="0">
+              <a:buNone/>
+            </a:pPr>
+            <a:r>
+              <a:rPr lang="en-US" sz="1400" dirty="0">
+                <a:solidFill>
+                  <a:schemeClr val="tx1"/>
+                </a:solidFill>
+              </a:rPr>
+              <a:t>A walk-round count can’t tell a bag from a person, or a busy day from a quiet one.</a:t>
+            </a:r>
+            <a:endParaRPr lang="en-US" sz="1400" dirty="0"/>
+          </a:p>
+        </p:txBody>
+      </p:sp>
+      <p:pic>
+        <p:nvPicPr>
+          <p:cNvPr id="9" name="Cartoon panel 3" descr="Panel 3, The spreadsheet: a &quot;Seat plan.xlsx&quot; grid full of question marks with a &quot;March!&quot; sticky note; the administrator scratches their head: &quot;Is this even up to date?&quot;">    </p:cNvPr>
+          <p:cNvPicPr>
+            <a:picLocks noChangeAspect="1"/>
+          </p:cNvPicPr>
+          <p:nvPr/>
+        </p:nvPicPr>
+        <p:blipFill>
+          <a:blip r:embed="rId4"/>
+          <a:stretch>
+            <a:fillRect/>
+          </a:stretch>
+        </p:blipFill>
+        <p:spPr>
+          <a:xfrm>
+            <a:off x="6193536" y="1691640"/>
+            <a:ext cx="2670048" cy="3115056"/>
+          </a:xfrm>
+          <a:prstGeom prst="rect">
+            <a:avLst/>
+          </a:prstGeom>
+        </p:spPr>
+      </p:pic>
+      <p:sp>
+        <p:nvSpPr>
+          <p:cNvPr id="10" name="Panel caption 3"/>
+          <p:cNvSpPr txBox="1"/>
+          <p:nvPr/>
+        </p:nvSpPr>
+        <p:spPr>
+          <a:xfrm>
+            <a:off x="6193536" y="4934712"/>
+            <a:ext cx="2670048" cy="685800"/>
+          </a:xfrm>
+          <a:prstGeom prst="rect">
+            <a:avLst/>
+          </a:prstGeom>
+          <a:noFill/>
+          <a:ln/>
+        </p:spPr>
+        <p:txBody>
+          <a:bodyPr wrap="square" lIns="0" tIns="0" rIns="0" bIns="0" rtlCol="0" anchor="t"/>
+          <a:lstStyle/>
+          <a:p>
+            <a:pPr indent="0" marL="0">
+              <a:buNone/>
+            </a:pPr>
+            <a:r>
+              <a:rPr lang="en-US" sz="1400" dirty="0">
+                <a:solidFill>
+                  <a:schemeClr val="tx1"/>
+                </a:solidFill>
+              </a:rPr>
+              <a:t>The seat plan spreadsheet is months out of date.</a:t>
+            </a:r>
+            <a:endParaRPr lang="en-US" sz="1400" dirty="0"/>
+          </a:p>
+        </p:txBody>
+      </p:sp>
+      <p:pic>
+        <p:nvPicPr>
+          <p:cNvPr id="11" name="Cartoon panel 4" descr="Panel 4, Yes… no… maybe?: a DDAP team lead on the phone asks &quot;Can we move in Monday?&quot; and the administrator replies &quot;Let me get back to you…&quot;">    </p:cNvPr>
+          <p:cNvPicPr>
+            <a:picLocks noChangeAspect="1"/>
+          </p:cNvPicPr>
+          <p:nvPr/>
+        </p:nvPicPr>
+        <p:blipFill>
+          <a:blip r:embed="rId5"/>
+          <a:stretch>
+            <a:fillRect/>
+          </a:stretch>
+        </p:blipFill>
+        <p:spPr>
+          <a:xfrm>
+            <a:off x="9061704" y="1691640"/>
+            <a:ext cx="2670048" cy="3115056"/>
+          </a:xfrm>
+          <a:prstGeom prst="rect">
+            <a:avLst/>
+          </a:prstGeom>
+        </p:spPr>
+      </p:pic>
+      <p:sp>
+        <p:nvSpPr>
+          <p:cNvPr id="12" name="Panel caption 4"/>
+          <p:cNvSpPr txBox="1"/>
+          <p:nvPr/>
+        </p:nvSpPr>
+        <p:spPr>
+          <a:xfrm>
+            <a:off x="9061704" y="4934712"/>
+            <a:ext cx="2670048" cy="685800"/>
+          </a:xfrm>
+          <a:prstGeom prst="rect">
+            <a:avLst/>
+          </a:prstGeom>
+          <a:noFill/>
+          <a:ln/>
+        </p:spPr>
+        <p:txBody>
+          <a:bodyPr wrap="square" lIns="0" tIns="0" rIns="0" bIns="0" rtlCol="0" anchor="t"/>
+          <a:lstStyle/>
+          <a:p>
+            <a:pPr indent="0" marL="0">
+              <a:buNone/>
+            </a:pPr>
+            <a:r>
+              <a:rPr lang="en-US" sz="1400" dirty="0">
+                <a:solidFill>
+                  <a:schemeClr val="tx1"/>
+                </a:solidFill>
+              </a:rPr>
+              <a:t>So the team gets a “maybe” instead of an answer.</a:t>
+            </a:r>
+            <a:endParaRPr lang="en-US" sz="1400" dirty="0"/>
+          </a:p>
+        </p:txBody>
+      </p:sp>
+      <p:sp>
+        <p:nvSpPr>
+          <p:cNvPr id="13" name="Takeaway card"/>
+          <p:cNvSpPr/>
+          <p:nvPr/>
+        </p:nvSpPr>
+        <p:spPr>
+          <a:xfrm>
+            <a:off x="457200" y="5760720"/>
+            <a:ext cx="11274552" cy="603504"/>
+          </a:xfrm>
+          <a:prstGeom prst="roundRect">
+            <a:avLst>
+              <a:gd name="adj" fmla="val 15152"/>
+            </a:avLst>
+          </a:prstGeom>
+          <a:solidFill>
+            <a:schemeClr val="accent6">
+              <a:alpha val="12000"/>
+            </a:schemeClr>
+          </a:solidFill>
+          <a:ln w="12700">
+            <a:solidFill>
+              <a:schemeClr val="accent6">
+                <a:alpha val="12000"/>
+              </a:schemeClr>
+            </a:solidFill>
+            <a:prstDash val="solid"/>
+          </a:ln>
+        </p:spPr>
+      </p:sp>
+      <p:sp>
+        <p:nvSpPr>
+          <p:cNvPr id="14" name="Takeaway"/>
+          <p:cNvSpPr txBox="1"/>
+          <p:nvPr/>
+        </p:nvSpPr>
+        <p:spPr>
+          <a:xfrm>
+            <a:off x="685800" y="5760720"/>
+            <a:ext cx="10835640" cy="603504"/>
+          </a:xfrm>
+          <a:prstGeom prst="rect">
+            <a:avLst/>
+          </a:prstGeom>
+          <a:noFill/>
+          <a:ln/>
+        </p:spPr>
+        <p:txBody>
+          <a:bodyPr wrap="square" lIns="0" tIns="0" rIns="0" bIns="0" rtlCol="0" anchor="ctr"/>
+          <a:lstStyle/>
+          <a:p>
+            <a:pPr indent="0" marL="0">
+              <a:buNone/>
+            </a:pPr>
+            <a:r>
+              <a:rPr lang="en-US" sz="1600" b="1" dirty="0">
+                <a:solidFill>
+                  <a:schemeClr val="accent6"/>
+                </a:solidFill>
+              </a:rPr>
+              <a:t>The cost: </a:t>
+            </a:r>
+            <a:pPr indent="0" marL="0">
+              <a:buNone/>
+            </a:pPr>
+            <a:r>
+              <a:rPr lang="en-US" sz="1600" dirty="0">
+                <a:solidFill>
+                  <a:schemeClr val="tx1"/>
+                </a:solidFill>
+              </a:rPr>
+              <a:t>slow, gut-feel answers: teams turned away from space that is actually free, or squeezed onto a floor that is already full.</a:t>
+            </a:r>
+            <a:endParaRPr lang="en-US" sz="1600" dirty="0"/>
+          </a:p>
+        </p:txBody>
+      </p:sp>
+    </p:spTree>
+  </p:cSld>
+  <p:clrMapOvr>
+    <a:masterClrMapping/>
+  </p:clrMapOvr>
+</p:sld>
+</file>
+
+<file path=ppt/slides/slide3.xml><?xml version="1.0" encoding="utf-8"?>
+<p:sld xmlns:a="http://schemas.openxmlformats.org/drawingml/2006/main" xmlns:r="http://schemas.openxmlformats.org/officeDocument/2006/relationships" xmlns:p="http://schemas.openxmlformats.org/presentationml/2006/main">
+  <p:cSld name="Slide 3">
     <p:spTree>
       <p:nvGrpSpPr>
         <p:cNvPr id="1" name=""/>

</xml_diff>